<commit_message>
Early Warning Watchlist, real-data demo opening, README screenshots, deck and docs update
</commit_message>
<xml_diff>
--- a/docs/presentation/Risk_Signal_Engine.pptx
+++ b/docs/presentation/Risk_Signal_Engine.pptx
@@ -858,7 +858,7 @@
           <a:lstStyle/>
           <a:p>
             <a:r>
-              <a:t>State the caveat plainly: the evaluation labels were drafted by an AI assistant and are pending human review, and the same assistant wrote the rules, so those numbers are a smoke test. Replaying 911 real captured documents, our false-trigger fixes cut simulated stress runs from 84 to 50 and removed every run triggered by social posts alone.</a:t>
+              <a:t>State the caveat plainly: the evaluation labels were drafted by an AI assistant and are pending human review, and the same assistant wrote the rules, so those numbers are a smoke test. Replaying 911 real captured documents, our false-trigger fixes cut simulated stress runs from 84 to 50 and removed every run triggered by social posts alone. The watchlist is the credit analyst's view: every held issuer gets a rules-based status from its recent signals; it is an attention flag, not a rating.</a:t>
             </a:r>
           </a:p>
         </p:txBody>
@@ -6174,7 +6174,7 @@
                 </a:solidFill>
                 <a:latin typeface="Calibri"/>
               </a:rPr>
-              <a:t>12 sections and explanations</a:t>
+              <a:t>12 sections and a watchlist</a:t>
             </a:r>
           </a:p>
         </p:txBody>
@@ -8603,7 +8603,7 @@
         <p:spPr>
           <a:xfrm>
             <a:off x="548640" y="3337560"/>
-            <a:ext cx="5789864" cy="1801291"/>
+            <a:ext cx="6388701" cy="1987596"/>
           </a:xfrm>
           <a:prstGeom prst="rect">
             <a:avLst/>
@@ -8617,7 +8617,7 @@
       </p:pic>
       <p:pic>
         <p:nvPicPr>
-          <p:cNvPr id="26" name="Picture 25" descr="signals_charts.png"/>
+          <p:cNvPr id="26" name="Picture 25" descr="watchlist.png"/>
           <p:cNvPicPr>
             <a:picLocks noChangeAspect="1"/>
           </p:cNvPicPr>
@@ -8631,8 +8631,8 @@
         </p:blipFill>
         <p:spPr>
           <a:xfrm>
-            <a:off x="6567104" y="3337560"/>
-            <a:ext cx="5075946" cy="1801291"/>
+            <a:off x="7165941" y="3337560"/>
+            <a:ext cx="4477110" cy="1987596"/>
           </a:xfrm>
           <a:prstGeom prst="rect">
             <a:avLst/>
@@ -8652,8 +8652,8 @@
         </p:nvSpPr>
         <p:spPr>
           <a:xfrm>
-            <a:off x="548640" y="5276011"/>
-            <a:ext cx="11064240" cy="457200"/>
+            <a:off x="548640" y="5370876"/>
+            <a:ext cx="6388701" cy="274320"/>
           </a:xfrm>
           <a:prstGeom prst="rect">
             <a:avLst/>
@@ -8668,36 +8668,27 @@
           <a:p>
             <a:pPr algn="l"/>
             <a:r>
-              <a:rPr sz="1800" b="1" i="0">
-                <a:solidFill>
-                  <a:srgbClr val="1F2A44"/>
-                </a:solidFill>
-                <a:latin typeface="Calibri"/>
-              </a:rPr>
-              <a:t>Business impact: </a:t>
-            </a:r>
-            <a:r>
-              <a:rPr sz="1800" b="0" i="0">
-                <a:solidFill>
-                  <a:srgbClr val="1A1A1A"/>
-                </a:solidFill>
-                <a:latin typeface="Calibri"/>
-              </a:rPr>
-              <a:t>earlier warning, triage by materiality, an audited portfolio view in seconds. Decision support, not investment advice.</a:t>
-            </a:r>
-          </a:p>
-        </p:txBody>
-      </p:sp>
-      <p:sp>
-        <p:nvSpPr>
-          <p:cNvPr id="28" name="Footer"/>
+              <a:rPr sz="1200" b="0" i="1">
+                <a:solidFill>
+                  <a:srgbClr val="555B66"/>
+                </a:solidFill>
+                <a:latin typeface="Calibri"/>
+              </a:rPr>
+              <a:t>Executive overview after the SYNTHETIC demo story</a:t>
+            </a:r>
+          </a:p>
+        </p:txBody>
+      </p:sp>
+      <p:sp>
+        <p:nvSpPr>
+          <p:cNvPr id="28" name="TextBox 27"/>
           <p:cNvSpPr txBox="1"/>
           <p:nvPr/>
         </p:nvSpPr>
         <p:spPr>
           <a:xfrm>
-            <a:off x="548640" y="6446520"/>
-            <a:ext cx="8686800" cy="274320"/>
+            <a:off x="7165941" y="5370876"/>
+            <a:ext cx="4477110" cy="274320"/>
           </a:xfrm>
           <a:prstGeom prst="rect">
             <a:avLst/>
@@ -8712,6 +8703,85 @@
           <a:p>
             <a:pPr algn="l"/>
             <a:r>
+              <a:rPr sz="1200" b="0" i="1">
+                <a:solidFill>
+                  <a:srgbClr val="555B66"/>
+                </a:solidFill>
+                <a:latin typeface="Calibri"/>
+              </a:rPr>
+              <a:t>Watchlist: Tata Motors WATCH-NEGATIVE after the downgrade</a:t>
+            </a:r>
+          </a:p>
+        </p:txBody>
+      </p:sp>
+      <p:sp>
+        <p:nvSpPr>
+          <p:cNvPr id="29" name="TextBox 28"/>
+          <p:cNvSpPr txBox="1"/>
+          <p:nvPr/>
+        </p:nvSpPr>
+        <p:spPr>
+          <a:xfrm>
+            <a:off x="548640" y="5736636"/>
+            <a:ext cx="11064240" cy="731520"/>
+          </a:xfrm>
+          <a:prstGeom prst="rect">
+            <a:avLst/>
+          </a:prstGeom>
+          <a:noFill/>
+        </p:spPr>
+        <p:txBody>
+          <a:bodyPr wrap="square" anchor="t" lIns="0" rIns="0" tIns="0" bIns="0">
+            <a:spAutoFit/>
+          </a:bodyPr>
+          <a:lstStyle/>
+          <a:p>
+            <a:pPr algn="l"/>
+            <a:r>
+              <a:rPr sz="1800" b="1" i="0">
+                <a:solidFill>
+                  <a:srgbClr val="1F2A44"/>
+                </a:solidFill>
+                <a:latin typeface="Calibri"/>
+              </a:rPr>
+              <a:t>Business impact: </a:t>
+            </a:r>
+            <a:r>
+              <a:rPr sz="1800" b="0" i="0">
+                <a:solidFill>
+                  <a:srgbClr val="1A1A1A"/>
+                </a:solidFill>
+                <a:latin typeface="Calibri"/>
+              </a:rPr>
+              <a:t>earlier warning on held names, triage by materiality, an audited portfolio view.</a:t>
+            </a:r>
+          </a:p>
+        </p:txBody>
+      </p:sp>
+      <p:sp>
+        <p:nvSpPr>
+          <p:cNvPr id="30" name="Footer"/>
+          <p:cNvSpPr txBox="1"/>
+          <p:nvPr/>
+        </p:nvSpPr>
+        <p:spPr>
+          <a:xfrm>
+            <a:off x="548640" y="6446520"/>
+            <a:ext cx="8686800" cy="274320"/>
+          </a:xfrm>
+          <a:prstGeom prst="rect">
+            <a:avLst/>
+          </a:prstGeom>
+          <a:noFill/>
+        </p:spPr>
+        <p:txBody>
+          <a:bodyPr wrap="square" anchor="t" lIns="0" rIns="0" tIns="0" bIns="0">
+            <a:spAutoFit/>
+          </a:bodyPr>
+          <a:lstStyle/>
+          <a:p>
+            <a:pPr algn="l"/>
+            <a:r>
               <a:rPr sz="1100" b="0" i="0">
                 <a:solidFill>
                   <a:srgbClr val="555B66"/>
@@ -8725,7 +8795,7 @@
       </p:sp>
       <p:sp>
         <p:nvSpPr>
-          <p:cNvPr id="29" name="SlideNo"/>
+          <p:cNvPr id="31" name="SlideNo"/>
           <p:cNvSpPr txBox="1"/>
           <p:nvPr/>
         </p:nvSpPr>

</xml_diff>

<commit_message>
Task F (2/3): dark-theme screenshots (full pages + 1366x768/1920x1080), compact watchlist table that fits at 1366, deck with the propagation graph on slide 5 and watchlist + credit brief on slide 6, README screenshots/features/API examples, DoSelect answer (1,088 words, 19/19)
</commit_message>
<xml_diff>
--- a/docs/presentation/Risk_Signal_Engine.pptx
+++ b/docs/presentation/Risk_Signal_Engine.pptx
@@ -788,7 +788,7 @@
           <a:lstStyle/>
           <a:p>
             <a:r>
-              <a:t>Read the disclaimer aloud. In the demo the Tata Motors downgrade triggers an issuer-only stress; our CDS hedge offsets much of it. The invasion headline triggers a moderate systemic stress; a second independent source escalates it to severe, above our 2% risk appetite.</a:t>
+              <a:t>Read the disclaimer aloud. In the demo the Tata Motors downgrade triggers an issuer-only stress; our CDS hedge offsets much of it. The invasion headline triggers a moderate systemic stress; a second independent source escalates it to severe, above our 2% risk appetite. The propagation graph shows what else in the book is linked to the issuer: the links are curated by hand and documented.</a:t>
             </a:r>
           </a:p>
         </p:txBody>
@@ -858,7 +858,7 @@
           <a:lstStyle/>
           <a:p>
             <a:r>
-              <a:t>State the caveat plainly: the evaluation labels were drafted by an AI assistant and are pending human review, and the same assistant wrote the rules, so those numbers are a smoke test. Replaying 911 real captured documents, our false-trigger fixes cut simulated stress runs from 84 to 50 and removed every run triggered by social posts alone. The watchlist is the credit analyst's view: every held issuer gets a rules-based status from its recent signals; it is an attention flag, not a rating.</a:t>
+              <a:t>State the caveat plainly: the evaluation labels were drafted by an AI assistant and are pending human review, and the same assistant wrote the rules, so those numbers are a smoke test. Replaying 911 real captured documents, our false-trigger fixes cut simulated stress runs from 84 to 50 and removed every run triggered by social posts alone. The watchlist is the credit analyst's view on real captured news; the credit brief is filled from templates, not generated by a language model.</a:t>
             </a:r>
           </a:p>
         </p:txBody>
@@ -6174,7 +6174,7 @@
                 </a:solidFill>
                 <a:latin typeface="Calibri"/>
               </a:rPr>
-              <a:t>12 sections and a watchlist</a:t>
+              <a:t>watchlist, propagation, what-if, brief</a:t>
             </a:r>
           </a:p>
         </p:txBody>
@@ -6963,7 +6963,7 @@
         <p:spPr>
           <a:xfrm>
             <a:off x="5623560" y="1371600"/>
-            <a:ext cx="6035040" cy="1931213"/>
+            <a:ext cx="6035040" cy="1670413"/>
           </a:xfrm>
           <a:prstGeom prst="rect">
             <a:avLst/>
@@ -6983,7 +6983,7 @@
         </p:nvSpPr>
         <p:spPr>
           <a:xfrm>
-            <a:off x="5623560" y="3366821"/>
+            <a:off x="5623560" y="3106021"/>
             <a:ext cx="6035040" cy="274320"/>
           </a:xfrm>
           <a:prstGeom prst="rect">
@@ -7176,8 +7176,8 @@
         </p:nvSpPr>
         <p:spPr>
           <a:xfrm>
-            <a:off x="548640" y="1508760"/>
-            <a:ext cx="4297680" cy="3108960"/>
+            <a:off x="548640" y="1463040"/>
+            <a:ext cx="4343400" cy="2651760"/>
           </a:xfrm>
           <a:prstGeom prst="rect">
             <a:avLst/>
@@ -7192,7 +7192,7 @@
           <a:p>
             <a:pPr marL="274320" indent="-274320">
               <a:spcAft>
-                <a:spcPts val="1000"/>
+                <a:spcPts val="800"/>
               </a:spcAft>
               <a:buClr>
                 <a:srgbClr val="0E8A84"/>
@@ -7201,7 +7201,7 @@
               <a:buChar char="•"/>
             </a:pPr>
             <a:r>
-              <a:rPr sz="1800" b="0" i="0">
+              <a:rPr sz="1700" b="0" i="0">
                 <a:solidFill>
                   <a:srgbClr val="1A1A1A"/>
                 </a:solidFill>
@@ -7213,7 +7213,7 @@
           <a:p>
             <a:pPr marL="274320" indent="-274320">
               <a:spcAft>
-                <a:spcPts val="1000"/>
+                <a:spcPts val="800"/>
               </a:spcAft>
               <a:buClr>
                 <a:srgbClr val="0E8A84"/>
@@ -7222,7 +7222,7 @@
               <a:buChar char="•"/>
             </a:pPr>
             <a:r>
-              <a:rPr sz="1800" b="0" i="0">
+              <a:rPr sz="1700" b="0" i="0">
                 <a:solidFill>
                   <a:srgbClr val="1A1A1A"/>
                 </a:solidFill>
@@ -7234,7 +7234,7 @@
           <a:p>
             <a:pPr marL="274320" indent="-274320">
               <a:spcAft>
-                <a:spcPts val="1000"/>
+                <a:spcPts val="800"/>
               </a:spcAft>
               <a:buClr>
                 <a:srgbClr val="0E8A84"/>
@@ -7243,7 +7243,7 @@
               <a:buChar char="•"/>
             </a:pPr>
             <a:r>
-              <a:rPr sz="1800" b="0" i="0">
+              <a:rPr sz="1700" b="0" i="0">
                 <a:solidFill>
                   <a:srgbClr val="1A1A1A"/>
                 </a:solidFill>
@@ -7255,7 +7255,7 @@
           <a:p>
             <a:pPr marL="274320" indent="-274320">
               <a:spcAft>
-                <a:spcPts val="1000"/>
+                <a:spcPts val="800"/>
               </a:spcAft>
               <a:buClr>
                 <a:srgbClr val="0E8A84"/>
@@ -7264,13 +7264,13 @@
               <a:buChar char="•"/>
             </a:pPr>
             <a:r>
-              <a:rPr sz="1800" b="0" i="0">
+              <a:rPr sz="1700" b="0" i="0">
                 <a:solidFill>
                   <a:srgbClr val="1A1A1A"/>
                 </a:solidFill>
                 <a:latin typeface="Calibri"/>
               </a:rPr>
-              <a:t>Cooldown and an audit trail for every run</a:t>
+              <a:t>What-if sliders reprice the book instantly</a:t>
             </a:r>
           </a:p>
         </p:txBody>
@@ -7283,8 +7283,8 @@
         </p:nvSpPr>
         <p:spPr>
           <a:xfrm>
-            <a:off x="548640" y="4617720"/>
-            <a:ext cx="256032" cy="256032"/>
+            <a:off x="548640" y="4251960"/>
+            <a:ext cx="237744" cy="237744"/>
           </a:xfrm>
           <a:prstGeom prst="ellipse">
             <a:avLst/>
@@ -7327,8 +7327,8 @@
         </p:nvSpPr>
         <p:spPr>
           <a:xfrm>
-            <a:off x="960120" y="4526280"/>
-            <a:ext cx="3931920" cy="457200"/>
+            <a:off x="932688" y="4160520"/>
+            <a:ext cx="3931920" cy="420624"/>
           </a:xfrm>
           <a:prstGeom prst="rect">
             <a:avLst/>
@@ -7343,7 +7343,7 @@
           <a:p>
             <a:pPr algn="l"/>
             <a:r>
-              <a:rPr sz="1900" b="1" i="0">
+              <a:rPr sz="1800" b="1" i="0">
                 <a:solidFill>
                   <a:srgbClr val="0CA30C"/>
                 </a:solidFill>
@@ -7352,7 +7352,7 @@
               <a:t>0.41% GREEN  </a:t>
             </a:r>
             <a:r>
-              <a:rPr sz="1800" b="0" i="0">
+              <a:rPr sz="1700" b="0" i="0">
                 <a:solidFill>
                   <a:srgbClr val="1A1A1A"/>
                 </a:solidFill>
@@ -7371,8 +7371,8 @@
         </p:nvSpPr>
         <p:spPr>
           <a:xfrm>
-            <a:off x="548640" y="5166360"/>
-            <a:ext cx="256032" cy="256032"/>
+            <a:off x="548640" y="4709160"/>
+            <a:ext cx="237744" cy="237744"/>
           </a:xfrm>
           <a:prstGeom prst="ellipse">
             <a:avLst/>
@@ -7415,8 +7415,8 @@
         </p:nvSpPr>
         <p:spPr>
           <a:xfrm>
-            <a:off x="960120" y="5074920"/>
-            <a:ext cx="3931920" cy="457200"/>
+            <a:off x="932688" y="4617720"/>
+            <a:ext cx="3931920" cy="420624"/>
           </a:xfrm>
           <a:prstGeom prst="rect">
             <a:avLst/>
@@ -7431,7 +7431,7 @@
           <a:p>
             <a:pPr algn="l"/>
             <a:r>
-              <a:rPr sz="1900" b="1" i="0">
+              <a:rPr sz="1800" b="1" i="0">
                 <a:solidFill>
                   <a:srgbClr val="C98A00"/>
                 </a:solidFill>
@@ -7440,7 +7440,7 @@
               <a:t>1.32% AMBER  </a:t>
             </a:r>
             <a:r>
-              <a:rPr sz="1800" b="0" i="0">
+              <a:rPr sz="1700" b="0" i="0">
                 <a:solidFill>
                   <a:srgbClr val="1A1A1A"/>
                 </a:solidFill>
@@ -7459,8 +7459,8 @@
         </p:nvSpPr>
         <p:spPr>
           <a:xfrm>
-            <a:off x="548640" y="5715000"/>
-            <a:ext cx="256032" cy="256032"/>
+            <a:off x="548640" y="5166360"/>
+            <a:ext cx="237744" cy="237744"/>
           </a:xfrm>
           <a:prstGeom prst="ellipse">
             <a:avLst/>
@@ -7503,8 +7503,8 @@
         </p:nvSpPr>
         <p:spPr>
           <a:xfrm>
-            <a:off x="960120" y="5623560"/>
-            <a:ext cx="3931920" cy="457200"/>
+            <a:off x="932688" y="5074920"/>
+            <a:ext cx="3931920" cy="420624"/>
           </a:xfrm>
           <a:prstGeom prst="rect">
             <a:avLst/>
@@ -7519,7 +7519,7 @@
           <a:p>
             <a:pPr algn="l"/>
             <a:r>
-              <a:rPr sz="1900" b="1" i="0">
+              <a:rPr sz="1800" b="1" i="0">
                 <a:solidFill>
                   <a:srgbClr val="D03B3B"/>
                 </a:solidFill>
@@ -7528,20 +7528,55 @@
               <a:t>2.45% RED  </a:t>
             </a:r>
             <a:r>
-              <a:rPr sz="1800" b="0" i="0">
+              <a:rPr sz="1700" b="0" i="0">
                 <a:solidFill>
                   <a:srgbClr val="1A1A1A"/>
                 </a:solidFill>
                 <a:latin typeface="Calibri"/>
               </a:rPr>
               <a:t>Corroborated (2 sources)</a:t>
+            </a:r>
+          </a:p>
+        </p:txBody>
+      </p:sp>
+      <p:sp>
+        <p:nvSpPr>
+          <p:cNvPr id="11" name="TextBox 10"/>
+          <p:cNvSpPr txBox="1"/>
+          <p:nvPr/>
+        </p:nvSpPr>
+        <p:spPr>
+          <a:xfrm>
+            <a:off x="548640" y="5577840"/>
+            <a:ext cx="4343400" cy="640080"/>
+          </a:xfrm>
+          <a:prstGeom prst="rect">
+            <a:avLst/>
+          </a:prstGeom>
+          <a:noFill/>
+        </p:spPr>
+        <p:txBody>
+          <a:bodyPr wrap="square" anchor="t" lIns="0" rIns="0" tIns="0" bIns="0">
+            <a:spAutoFit/>
+          </a:bodyPr>
+          <a:lstStyle/>
+          <a:p>
+            <a:pPr algn="l"/>
+            <a:r>
+              <a:rPr sz="1300" b="1" i="0">
+                <a:solidFill>
+                  <a:srgbClr val="D03B3B"/>
+                </a:solidFill>
+                <a:latin typeface="Calibri"/>
+              </a:rPr>
+              <a:t>Simplified, illustrative hackathon stress model. Not a production or regulatory risk model.</a:t>
             </a:r>
           </a:p>
         </p:txBody>
       </p:sp>
       <p:pic>
         <p:nvPicPr>
-          <p:cNvPr id="11" name="Picture 10" descr="stress_waterfall.png"/>
+          <p:cNvPr id="12" name="Picture 11" descr="stress_waterfall.png"/>
           <p:cNvPicPr>
             <a:picLocks noChangeAspect="1"/>
           </p:cNvPicPr>
@@ -7555,8 +7590,8 @@
         </p:blipFill>
         <p:spPr>
           <a:xfrm>
-            <a:off x="5166360" y="1508760"/>
-            <a:ext cx="6492240" cy="2478855"/>
+            <a:off x="5120640" y="1417320"/>
+            <a:ext cx="6537960" cy="2451735"/>
           </a:xfrm>
           <a:prstGeom prst="rect">
             <a:avLst/>
@@ -7570,14 +7605,14 @@
       </p:pic>
       <p:sp>
         <p:nvSpPr>
-          <p:cNvPr id="12" name="TextBox 11"/>
+          <p:cNvPr id="13" name="TextBox 12"/>
           <p:cNvSpPr txBox="1"/>
           <p:nvPr/>
         </p:nvSpPr>
         <p:spPr>
           <a:xfrm>
-            <a:off x="5166360" y="4079055"/>
-            <a:ext cx="6492240" cy="274320"/>
+            <a:off x="5120640" y="3896487"/>
+            <a:ext cx="6537960" cy="274320"/>
           </a:xfrm>
           <a:prstGeom prst="rect">
             <a:avLst/>
@@ -7603,16 +7638,45 @@
           </a:p>
         </p:txBody>
       </p:sp>
-      <p:sp>
-        <p:nvSpPr>
-          <p:cNvPr id="13" name="TextBox 12"/>
+      <p:pic>
+        <p:nvPicPr>
+          <p:cNvPr id="14" name="Picture 13" descr="propagation_graph.png"/>
+          <p:cNvPicPr>
+            <a:picLocks noChangeAspect="1"/>
+          </p:cNvPicPr>
+          <p:nvPr/>
+        </p:nvPicPr>
+        <p:blipFill>
+          <a:blip r:embed="rId3"/>
+          <a:stretch>
+            <a:fillRect/>
+          </a:stretch>
+        </p:blipFill>
+        <p:spPr>
+          <a:xfrm>
+            <a:off x="5120640" y="4253103"/>
+            <a:ext cx="2769617" cy="2010537"/>
+          </a:xfrm>
+          <a:prstGeom prst="rect">
+            <a:avLst/>
+          </a:prstGeom>
+          <a:ln w="12700">
+            <a:solidFill>
+              <a:srgbClr val="C9D3DB"/>
+            </a:solidFill>
+          </a:ln>
+        </p:spPr>
+      </p:pic>
+      <p:sp>
+        <p:nvSpPr>
+          <p:cNvPr id="15" name="TextBox 14"/>
           <p:cNvSpPr txBox="1"/>
           <p:nvPr/>
         </p:nvSpPr>
         <p:spPr>
           <a:xfrm>
-            <a:off x="5166360" y="4444815"/>
-            <a:ext cx="6492240" cy="640080"/>
+            <a:off x="8118857" y="4253103"/>
+            <a:ext cx="3539743" cy="2010537"/>
           </a:xfrm>
           <a:prstGeom prst="rect">
             <a:avLst/>
@@ -7627,20 +7691,44 @@
           <a:p>
             <a:pPr algn="l"/>
             <a:r>
-              <a:rPr sz="1400" b="1" i="0">
-                <a:solidFill>
-                  <a:srgbClr val="D03B3B"/>
-                </a:solidFill>
-                <a:latin typeface="Calibri"/>
-              </a:rPr>
-              <a:t>Simplified, illustrative hackathon stress model. Not a production or regulatory risk model.</a:t>
-            </a:r>
-          </a:p>
-        </p:txBody>
-      </p:sp>
-      <p:sp>
-        <p:nvSpPr>
-          <p:cNvPr id="14" name="Footer"/>
+              <a:rPr sz="1800" b="1" i="0">
+                <a:solidFill>
+                  <a:srgbClr val="1F2A44"/>
+                </a:solidFill>
+                <a:latin typeface="Calibri"/>
+              </a:rPr>
+              <a:t>Risk propagation</a:t>
+            </a:r>
+          </a:p>
+          <a:p>
+            <a:pPr algn="l"/>
+            <a:r>
+              <a:rPr sz="1500" b="0" i="0">
+                <a:solidFill>
+                  <a:srgbClr val="1A1A1A"/>
+                </a:solidFill>
+                <a:latin typeface="Calibri"/>
+              </a:rPr>
+              <a:t>Direct vs second-order exposure over 16 hand-curated links (supplier, parent, peer). Tata Motors: $41m held, $23m more via Ford and Tesla.</a:t>
+            </a:r>
+          </a:p>
+          <a:p>
+            <a:pPr algn="l"/>
+            <a:r>
+              <a:rPr sz="1300" b="0" i="0">
+                <a:solidFill>
+                  <a:srgbClr val="555B66"/>
+                </a:solidFill>
+                <a:latin typeface="Calibri"/>
+              </a:rPr>
+              <a:t>Curated, not inferred; an attention measure, not a contagion model.</a:t>
+            </a:r>
+          </a:p>
+        </p:txBody>
+      </p:sp>
+      <p:sp>
+        <p:nvSpPr>
+          <p:cNvPr id="16" name="Footer"/>
           <p:cNvSpPr txBox="1"/>
           <p:nvPr/>
         </p:nvSpPr>
@@ -7675,7 +7763,7 @@
       </p:sp>
       <p:sp>
         <p:nvSpPr>
-          <p:cNvPr id="15" name="SlideNo"/>
+          <p:cNvPr id="17" name="SlideNo"/>
           <p:cNvSpPr txBox="1"/>
           <p:nvPr/>
         </p:nvSpPr>
@@ -7805,7 +7893,7 @@
         <p:spPr>
           <a:xfrm>
             <a:off x="548640" y="1417320"/>
-            <a:ext cx="2103120" cy="1417320"/>
+            <a:ext cx="2103120" cy="1325880"/>
           </a:xfrm>
           <a:prstGeom prst="roundRect">
             <a:avLst>
@@ -7850,7 +7938,7 @@
         </p:nvSpPr>
         <p:spPr>
           <a:xfrm>
-            <a:off x="713232" y="1508760"/>
+            <a:off x="713232" y="1490472"/>
             <a:ext cx="1828800" cy="548640"/>
           </a:xfrm>
           <a:prstGeom prst="rect">
@@ -7866,7 +7954,7 @@
           <a:p>
             <a:pPr algn="l"/>
             <a:r>
-              <a:rPr sz="3000" b="1" i="0">
+              <a:rPr sz="2800" b="1" i="0">
                 <a:solidFill>
                   <a:srgbClr val="1F2A44"/>
                 </a:solidFill>
@@ -7885,7 +7973,7 @@
         </p:nvSpPr>
         <p:spPr>
           <a:xfrm>
-            <a:off x="713232" y="2075688"/>
+            <a:off x="713232" y="2020824"/>
             <a:ext cx="1828800" cy="365760"/>
           </a:xfrm>
           <a:prstGeom prst="rect">
@@ -7920,7 +8008,7 @@
         </p:nvSpPr>
         <p:spPr>
           <a:xfrm>
-            <a:off x="713232" y="2404872"/>
+            <a:off x="713232" y="2331720"/>
             <a:ext cx="1828800" cy="320040"/>
           </a:xfrm>
           <a:prstGeom prst="rect">
@@ -7956,7 +8044,7 @@
         <p:spPr>
           <a:xfrm>
             <a:off x="2770632" y="1417320"/>
-            <a:ext cx="2103120" cy="1417320"/>
+            <a:ext cx="2103120" cy="1325880"/>
           </a:xfrm>
           <a:prstGeom prst="roundRect">
             <a:avLst>
@@ -8001,7 +8089,7 @@
         </p:nvSpPr>
         <p:spPr>
           <a:xfrm>
-            <a:off x="2935224" y="1508760"/>
+            <a:off x="2935224" y="1490472"/>
             <a:ext cx="1828800" cy="548640"/>
           </a:xfrm>
           <a:prstGeom prst="rect">
@@ -8017,7 +8105,7 @@
           <a:p>
             <a:pPr algn="l"/>
             <a:r>
-              <a:rPr sz="3000" b="1" i="0">
+              <a:rPr sz="2800" b="1" i="0">
                 <a:solidFill>
                   <a:srgbClr val="1F2A44"/>
                 </a:solidFill>
@@ -8036,7 +8124,7 @@
         </p:nvSpPr>
         <p:spPr>
           <a:xfrm>
-            <a:off x="2935224" y="2075688"/>
+            <a:off x="2935224" y="2020824"/>
             <a:ext cx="1828800" cy="365760"/>
           </a:xfrm>
           <a:prstGeom prst="rect">
@@ -8071,7 +8159,7 @@
         </p:nvSpPr>
         <p:spPr>
           <a:xfrm>
-            <a:off x="2935224" y="2404872"/>
+            <a:off x="2935224" y="2331720"/>
             <a:ext cx="1828800" cy="320040"/>
           </a:xfrm>
           <a:prstGeom prst="rect">
@@ -8107,7 +8195,7 @@
         <p:spPr>
           <a:xfrm>
             <a:off x="4992624" y="1417320"/>
-            <a:ext cx="2103120" cy="1417320"/>
+            <a:ext cx="2103120" cy="1325880"/>
           </a:xfrm>
           <a:prstGeom prst="roundRect">
             <a:avLst>
@@ -8152,7 +8240,7 @@
         </p:nvSpPr>
         <p:spPr>
           <a:xfrm>
-            <a:off x="5157216" y="1508760"/>
+            <a:off x="5157216" y="1490472"/>
             <a:ext cx="1828800" cy="548640"/>
           </a:xfrm>
           <a:prstGeom prst="rect">
@@ -8168,7 +8256,7 @@
           <a:p>
             <a:pPr algn="l"/>
             <a:r>
-              <a:rPr sz="3000" b="1" i="0">
+              <a:rPr sz="2800" b="1" i="0">
                 <a:solidFill>
                   <a:srgbClr val="1F2A44"/>
                 </a:solidFill>
@@ -8187,7 +8275,7 @@
         </p:nvSpPr>
         <p:spPr>
           <a:xfrm>
-            <a:off x="5157216" y="2075688"/>
+            <a:off x="5157216" y="2020824"/>
             <a:ext cx="1828800" cy="365760"/>
           </a:xfrm>
           <a:prstGeom prst="rect">
@@ -8222,7 +8310,7 @@
         </p:nvSpPr>
         <p:spPr>
           <a:xfrm>
-            <a:off x="5157216" y="2404872"/>
+            <a:off x="5157216" y="2331720"/>
             <a:ext cx="1828800" cy="320040"/>
           </a:xfrm>
           <a:prstGeom prst="rect">
@@ -8258,7 +8346,7 @@
         <p:spPr>
           <a:xfrm>
             <a:off x="7214616" y="1417320"/>
-            <a:ext cx="2103120" cy="1417320"/>
+            <a:ext cx="2103120" cy="1325880"/>
           </a:xfrm>
           <a:prstGeom prst="roundRect">
             <a:avLst>
@@ -8303,7 +8391,7 @@
         </p:nvSpPr>
         <p:spPr>
           <a:xfrm>
-            <a:off x="7379208" y="1508760"/>
+            <a:off x="7379208" y="1490472"/>
             <a:ext cx="1828800" cy="548640"/>
           </a:xfrm>
           <a:prstGeom prst="rect">
@@ -8319,7 +8407,7 @@
           <a:p>
             <a:pPr algn="l"/>
             <a:r>
-              <a:rPr sz="3000" b="1" i="0">
+              <a:rPr sz="2800" b="1" i="0">
                 <a:solidFill>
                   <a:srgbClr val="1F2A44"/>
                 </a:solidFill>
@@ -8338,7 +8426,7 @@
         </p:nvSpPr>
         <p:spPr>
           <a:xfrm>
-            <a:off x="7379208" y="2075688"/>
+            <a:off x="7379208" y="2020824"/>
             <a:ext cx="1828800" cy="365760"/>
           </a:xfrm>
           <a:prstGeom prst="rect">
@@ -8373,7 +8461,7 @@
         </p:nvSpPr>
         <p:spPr>
           <a:xfrm>
-            <a:off x="7379208" y="2404872"/>
+            <a:off x="7379208" y="2331720"/>
             <a:ext cx="1828800" cy="320040"/>
           </a:xfrm>
           <a:prstGeom prst="rect">
@@ -8409,7 +8497,7 @@
         <p:spPr>
           <a:xfrm>
             <a:off x="9436608" y="1417320"/>
-            <a:ext cx="2103120" cy="1417320"/>
+            <a:ext cx="2103120" cy="1325880"/>
           </a:xfrm>
           <a:prstGeom prst="roundRect">
             <a:avLst>
@@ -8454,7 +8542,7 @@
         </p:nvSpPr>
         <p:spPr>
           <a:xfrm>
-            <a:off x="9601200" y="1508760"/>
+            <a:off x="9601200" y="1490472"/>
             <a:ext cx="1828800" cy="548640"/>
           </a:xfrm>
           <a:prstGeom prst="rect">
@@ -8470,7 +8558,7 @@
           <a:p>
             <a:pPr algn="l"/>
             <a:r>
-              <a:rPr sz="3000" b="1" i="0">
+              <a:rPr sz="2800" b="1" i="0">
                 <a:solidFill>
                   <a:srgbClr val="1F2A44"/>
                 </a:solidFill>
@@ -8489,7 +8577,7 @@
         </p:nvSpPr>
         <p:spPr>
           <a:xfrm>
-            <a:off x="9601200" y="2075688"/>
+            <a:off x="9601200" y="2020824"/>
             <a:ext cx="1828800" cy="365760"/>
           </a:xfrm>
           <a:prstGeom prst="rect">
@@ -8524,7 +8612,7 @@
         </p:nvSpPr>
         <p:spPr>
           <a:xfrm>
-            <a:off x="9601200" y="2404872"/>
+            <a:off x="9601200" y="2331720"/>
             <a:ext cx="1828800" cy="320040"/>
           </a:xfrm>
           <a:prstGeom prst="rect">
@@ -8559,7 +8647,7 @@
         </p:nvSpPr>
         <p:spPr>
           <a:xfrm>
-            <a:off x="548640" y="2898648"/>
+            <a:off x="548640" y="2788920"/>
             <a:ext cx="10972800" cy="274320"/>
           </a:xfrm>
           <a:prstGeom prst="rect">
@@ -8588,7 +8676,7 @@
       </p:sp>
       <p:pic>
         <p:nvPicPr>
-          <p:cNvPr id="25" name="Picture 24" descr="home_kpis.png"/>
+          <p:cNvPr id="25" name="Picture 24" descr="watchlist.png"/>
           <p:cNvPicPr>
             <a:picLocks noChangeAspect="1"/>
           </p:cNvPicPr>
@@ -8602,8 +8690,8 @@
         </p:blipFill>
         <p:spPr>
           <a:xfrm>
-            <a:off x="548640" y="3337560"/>
-            <a:ext cx="6388701" cy="1987596"/>
+            <a:off x="548640" y="3200400"/>
+            <a:ext cx="4523232" cy="2423160"/>
           </a:xfrm>
           <a:prstGeom prst="rect">
             <a:avLst/>
@@ -8617,7 +8705,7 @@
       </p:pic>
       <p:pic>
         <p:nvPicPr>
-          <p:cNvPr id="26" name="Picture 25" descr="watchlist.png"/>
+          <p:cNvPr id="26" name="Picture 25" descr="credit_brief.png"/>
           <p:cNvPicPr>
             <a:picLocks noChangeAspect="1"/>
           </p:cNvPicPr>
@@ -8631,8 +8719,8 @@
         </p:blipFill>
         <p:spPr>
           <a:xfrm>
-            <a:off x="7165941" y="3337560"/>
-            <a:ext cx="4477110" cy="1987596"/>
+            <a:off x="5254752" y="3200400"/>
+            <a:ext cx="4621312" cy="2423160"/>
           </a:xfrm>
           <a:prstGeom prst="rect">
             <a:avLst/>
@@ -8652,8 +8740,8 @@
         </p:nvSpPr>
         <p:spPr>
           <a:xfrm>
-            <a:off x="548640" y="5370876"/>
-            <a:ext cx="6388701" cy="274320"/>
+            <a:off x="548640" y="5660136"/>
+            <a:ext cx="4523232" cy="274320"/>
           </a:xfrm>
           <a:prstGeom prst="rect">
             <a:avLst/>
@@ -8674,7 +8762,7 @@
                 </a:solidFill>
                 <a:latin typeface="Calibri"/>
               </a:rPr>
-              <a:t>Executive overview after the SYNTHETIC demo story</a:t>
+              <a:t>Early-warning watchlist (real data + SYNTHETIC story)</a:t>
             </a:r>
           </a:p>
         </p:txBody>
@@ -8687,8 +8775,8 @@
         </p:nvSpPr>
         <p:spPr>
           <a:xfrm>
-            <a:off x="7165941" y="5370876"/>
-            <a:ext cx="4477110" cy="274320"/>
+            <a:off x="5254752" y="5660136"/>
+            <a:ext cx="4621312" cy="274320"/>
           </a:xfrm>
           <a:prstGeom prst="rect">
             <a:avLst/>
@@ -8709,7 +8797,7 @@
                 </a:solidFill>
                 <a:latin typeface="Calibri"/>
               </a:rPr>
-              <a:t>Watchlist: Tata Motors WATCH-NEGATIVE after the downgrade</a:t>
+              <a:t>One-click credit brief (template, no LLM; PDF)</a:t>
             </a:r>
           </a:p>
         </p:txBody>
@@ -8722,8 +8810,8 @@
         </p:nvSpPr>
         <p:spPr>
           <a:xfrm>
-            <a:off x="548640" y="5736636"/>
-            <a:ext cx="11064240" cy="731520"/>
+            <a:off x="10104664" y="3200400"/>
+            <a:ext cx="1538391" cy="365760"/>
           </a:xfrm>
           <a:prstGeom prst="rect">
             <a:avLst/>
@@ -8744,23 +8832,100 @@
                 </a:solidFill>
                 <a:latin typeface="Calibri"/>
               </a:rPr>
-              <a:t>Business impact: </a:t>
-            </a:r>
-            <a:r>
-              <a:rPr sz="1800" b="0" i="0">
+              <a:t>Business impact</a:t>
+            </a:r>
+          </a:p>
+        </p:txBody>
+      </p:sp>
+      <p:sp>
+        <p:nvSpPr>
+          <p:cNvPr id="30" name="TextBox 29"/>
+          <p:cNvSpPr txBox="1"/>
+          <p:nvPr/>
+        </p:nvSpPr>
+        <p:spPr>
+          <a:xfrm>
+            <a:off x="10104664" y="3611880"/>
+            <a:ext cx="1538391" cy="2011680"/>
+          </a:xfrm>
+          <a:prstGeom prst="rect">
+            <a:avLst/>
+          </a:prstGeom>
+          <a:noFill/>
+        </p:spPr>
+        <p:txBody>
+          <a:bodyPr wrap="square" lIns="0" rIns="0" tIns="0" bIns="0">
+            <a:spAutoFit/>
+          </a:bodyPr>
+          <a:lstStyle/>
+          <a:p>
+            <a:pPr marL="274320" indent="-274320">
+              <a:spcAft>
+                <a:spcPts val="800"/>
+              </a:spcAft>
+              <a:buClr>
+                <a:srgbClr val="0E8A84"/>
+              </a:buClr>
+              <a:buFont typeface="Arial"/>
+              <a:buChar char="•"/>
+            </a:pPr>
+            <a:r>
+              <a:rPr sz="1400" b="0" i="0">
                 <a:solidFill>
                   <a:srgbClr val="1A1A1A"/>
                 </a:solidFill>
                 <a:latin typeface="Calibri"/>
               </a:rPr>
-              <a:t>earlier warning on held names, triage by materiality, an audited portfolio view.</a:t>
-            </a:r>
-          </a:p>
-        </p:txBody>
-      </p:sp>
-      <p:sp>
-        <p:nvSpPr>
-          <p:cNvPr id="30" name="Footer"/>
+              <a:t>Earlier warning on held names</a:t>
+            </a:r>
+          </a:p>
+          <a:p>
+            <a:pPr marL="274320" indent="-274320">
+              <a:spcAft>
+                <a:spcPts val="800"/>
+              </a:spcAft>
+              <a:buClr>
+                <a:srgbClr val="0E8A84"/>
+              </a:buClr>
+              <a:buFont typeface="Arial"/>
+              <a:buChar char="•"/>
+            </a:pPr>
+            <a:r>
+              <a:rPr sz="1400" b="0" i="0">
+                <a:solidFill>
+                  <a:srgbClr val="1A1A1A"/>
+                </a:solidFill>
+                <a:latin typeface="Calibri"/>
+              </a:rPr>
+              <a:t>Triage by materiality, rule shown</a:t>
+            </a:r>
+          </a:p>
+          <a:p>
+            <a:pPr marL="274320" indent="-274320">
+              <a:spcAft>
+                <a:spcPts val="800"/>
+              </a:spcAft>
+              <a:buClr>
+                <a:srgbClr val="0E8A84"/>
+              </a:buClr>
+              <a:buFont typeface="Arial"/>
+              <a:buChar char="•"/>
+            </a:pPr>
+            <a:r>
+              <a:rPr sz="1400" b="0" i="0">
+                <a:solidFill>
+                  <a:srgbClr val="1A1A1A"/>
+                </a:solidFill>
+                <a:latin typeface="Calibri"/>
+              </a:rPr>
+              <a:t>Audited portfolio view in seconds</a:t>
+            </a:r>
+          </a:p>
+        </p:txBody>
+      </p:sp>
+      <p:sp>
+        <p:nvSpPr>
+          <p:cNvPr id="31" name="Footer"/>
           <p:cNvSpPr txBox="1"/>
           <p:nvPr/>
         </p:nvSpPr>
@@ -8795,7 +8960,7 @@
       </p:sp>
       <p:sp>
         <p:nvSpPr>
-          <p:cNvPr id="31" name="SlideNo"/>
+          <p:cNvPr id="32" name="SlideNo"/>
           <p:cNvSpPr txBox="1"/>
           <p:nvPr/>
         </p:nvSpPr>

</xml_diff>

<commit_message>
Deck quality pass: no text under 18 pt, no overflow, speaker notes for a 5-minute pitch
- every text run on all 7 slides is at least 18 pt (footers, captions, card labels, legend); strings shortened,
  cards resized, architecture diagram enlarged, takeaway bar on slide 6, single preliminary label on slide 5
- speaker notes rewritten for a 5-minute live pitch (658 words, timings per slide), numbers read from the
  script outputs at build time
- previews re-rendered and docs/presentation.pdf exported with PowerPoint
</commit_message>
<xml_diff>
--- a/docs/presentation/Risk_Signal_Engine.pptx
+++ b/docs/presentation/Risk_Signal_Engine.pptx
@@ -508,7 +508,7 @@
           <a:lstStyle/>
           <a:p>
             <a:r>
-              <a:t>Every number in this deck is produced by a script in the repository or labelled as simulated or synthetic. One sentence: we turn news and social text into explainable risk signals and stress the portfolio when something material happens.</a:t>
+              <a:t>(30 s) Hello, I am Apeksha Jain from ABV-IIITM Gwalior. This is Risk Signal Engine, my individual submission for Module B, strategic portfolio stress testing. In one sentence: it reads news and social posts, turns each item into an explainable risk signal, and stress-tests the portfolio the moment something material happens. Every number I show comes from a script in the repository, or is labelled simulated.</a:t>
             </a:r>
           </a:p>
         </p:txBody>
@@ -578,7 +578,7 @@
           <a:lstStyle/>
           <a:p>
             <a:r>
-              <a:t>Frame it as decision support for risk managers, credit analysts and portfolio managers. We make no ROI or time-saved claim; the only speed number is the measured per-document latency.</a:t>
+              <a:t>(40 s) Credit risk shows up in text before it shows up in prices or ratings data: downgrades, regulatory probes, sanctions, rate surprises. Today an analyst reads the headline, decides whether it matters, and someone runs a stress test later, by hand. Nothing links the headline to the book's exposure in the moment. My approach: an NLP engine scores every item for sentiment, event type and a 1-to-10 impact, and an event-driven stress engine reprices the portfolio when a rule fires. The only speed claim I make is the measured one: a median of 204.7 milliseconds per document on a CPU laptop.</a:t>
             </a:r>
           </a:p>
         </p:txBody>
@@ -648,7 +648,7 @@
           <a:lstStyle/>
           <a:p>
             <a:r>
-              <a:t>Sources are only claimed after our probe script passed. Adapters never crash the app. The stress engine is a subscriber on the event bus. Everything runs offline after a one-time model download.</a:t>
+              <a:t>(45 s) Left to right. Real sources, Google News, Reddit and Mastodon, are used only because they passed our probe script; the others are skipped cleanly, and no adapter can crash the app. Everything, live, replayed, scripted or sent to the API, goes through one pipeline: cleaning and deduplication, entity resolution, FinBERT sentiment, event rules with evidence, and the impact score. Signals are stored and published on an event bus; the stress engine is a subscriber, and the FastAPI service and the Streamlit dashboard sit on top. Every record carries a provenance badge, and after a one-time model download the whole system runs offline.</a:t>
             </a:r>
           </a:p>
         </p:txBody>
@@ -718,7 +718,7 @@
           <a:lstStyle/>
           <a:p>
             <a:r>
-              <a:t>Walk through the formula with the example: event severity and strong negative sentiment dominate, the signal is market-wide, and two sources corroborate it. Weights are published at /methodology.</a:t>
+              <a:t>(45 s) Three highlights. First, explainability: every score is decomposed. The impact formula is on the slide with the published weights: event severity, sentiment magnitude, exposure and source credibility, scaled by confidence. They are expert priors, not calibrated, and the dashboard says so. Second, the stress engine: news-only triggers, systemic or issuer-specific, with cooldown and corroboration, and simple pricers for bonds, loans, swaps, CDS, FX and equity. Third, credit views: an early-warning watchlist, propagation over curated links, a one-click credit brief, and a time machine over the real captured history.</a:t>
             </a:r>
           </a:p>
         </p:txBody>
@@ -788,7 +788,7 @@
           <a:lstStyle/>
           <a:p>
             <a:r>
-              <a:t>State the caveat plainly: the evaluation labels were drafted by an AI assistant and are pending human review, and the same assistant wrote the rules, so those numbers are a smoke test. Replaying 911 real captured documents, our false-trigger fixes cut simulated stress runs from 84 to 50. Read the disclaimer aloud.</a:t>
+              <a:t>(60 s) Results, with n for every number. On 147 headlines and posts, FinBERT sentiment accuracy is 0.653, event classification 0.81, entity resolution 0.898. These labels were drafted by an AI assistant and are pending human review, so treat them as a smoke test. Median latency is 204.7 ms per document, p95 1085.2 ms, over 200 documents. Replaying 911 real captured documents, my false-trigger fixes cut simulated stress runs from 84 to 50. In the scripted demo, a Tata Motors downgrade gives 0.41% GREEN thanks to a CDS hedge; an invasion headline gives 1.32% AMBER; a second source corroborates it: 2.45% RED. These losses are simulated on a synthetic portfolio with an illustrative model, not investment advice.</a:t>
             </a:r>
           </a:p>
         </p:txBody>
@@ -858,7 +858,7 @@
           <a:lstStyle/>
           <a:p>
             <a:r>
-              <a:t>Business value without invented numbers: earlier attention on held names, triage by materiality with the reason shown, and an immediate, audited portfolio view. Linked exposure is an attention measure, not a contagion model.</a:t>
+              <a:t>(40 s) Who uses it. Credit analysts see which held names need attention and exactly which rule fired. Risk managers get an audited, simulated portfolio view when news breaks, instead of waiting for the next scheduled run. Portfolio managers see linked exposure and test their own shocks with the what-if sliders. I make no ROI or time-saved claim. The value is earlier attention, triage by materiality with the reason shown, and an audit trail from every stress run back to the headline that triggered it. Linked exposure is an attention measure, not a contagion model.</a:t>
             </a:r>
           </a:p>
         </p:txBody>
@@ -928,7 +928,7 @@
           <a:lstStyle/>
           <a:p>
             <a:r>
-              <a:t>Close on the takeaway. If asked about weaknesses, the limitations column is the honest list; docs/judge_qa.md has the answers.</a:t>
+              <a:t>(40 s) Honest limitations: the impact weights are uncalibrated priors, keyword rules still misfire on some real headlines, news is headline-only, the evaluation set is small and AI-labelled, and the stress model is illustrative on a synthetic portfolio. Next: calibrate impact on market moves, licensed full-text news, fine-tuned models from the ready training notebook, streaming and backtesting. What already works: provenance on every record, one pipeline for every input, and an offline demo on a laptop. Thank you, I am happy to take questions.</a:t>
             </a:r>
           </a:p>
         </p:txBody>
@@ -4074,13 +4074,13 @@
           <a:p>
             <a:pPr algn="l"/>
             <a:r>
-              <a:rPr sz="1700" b="0" i="0">
+              <a:rPr sz="1800" b="0" i="0">
                 <a:solidFill>
                   <a:srgbClr val="FFFFFF"/>
                 </a:solidFill>
                 <a:latin typeface="Calibri"/>
               </a:rPr>
-              <a:t>S&amp;P Global × CRISIL · Code to Connect Hackathon 2026 · Module B: Strategic Portfolio Stress Testing</a:t>
+              <a:t>S&amp;P Global × CRISIL · Code to Connect 2026 · Module B: Strategic Portfolio Stress Testing</a:t>
             </a:r>
           </a:p>
         </p:txBody>
@@ -4319,13 +4319,13 @@
           <a:p>
             <a:pPr algn="l"/>
             <a:r>
-              <a:rPr sz="1500" b="0" i="0">
+              <a:rPr sz="1800" b="0" i="0">
                 <a:solidFill>
                   <a:srgbClr val="555B66"/>
                 </a:solidFill>
                 <a:latin typeface="Calibri"/>
               </a:rPr>
-              <a:t>Individual submission · decision-support prototype, not investment advice</a:t>
+              <a:t>Apeksha Jain · ABV-IIITM Gwalior · individual submission · decision support, not investment advice</a:t>
             </a:r>
           </a:p>
         </p:txBody>
@@ -4613,7 +4613,7 @@
           <a:p>
             <a:pPr algn="ctr"/>
             <a:r>
-              <a:rPr sz="1700" b="1" i="0">
+              <a:rPr sz="1800" b="1" i="0">
                 <a:solidFill>
                   <a:srgbClr val="1F2A44"/>
                 </a:solidFill>
@@ -4704,7 +4704,7 @@
           <a:p>
             <a:pPr algn="ctr"/>
             <a:r>
-              <a:rPr sz="1700" b="1" i="0">
+              <a:rPr sz="1800" b="1" i="0">
                 <a:solidFill>
                   <a:srgbClr val="1F2A44"/>
                 </a:solidFill>
@@ -4795,7 +4795,7 @@
           <a:p>
             <a:pPr algn="ctr"/>
             <a:r>
-              <a:rPr sz="1700" b="1" i="0">
+              <a:rPr sz="1800" b="1" i="0">
                 <a:solidFill>
                   <a:srgbClr val="1F2A44"/>
                 </a:solidFill>
@@ -4885,7 +4885,7 @@
           <a:p>
             <a:pPr algn="ctr"/>
             <a:r>
-              <a:rPr sz="1700" b="1" i="0">
+              <a:rPr sz="1800" b="1" i="0">
                 <a:solidFill>
                   <a:srgbClr val="FFFFFF"/>
                 </a:solidFill>
@@ -4976,7 +4976,7 @@
           <a:p>
             <a:pPr algn="ctr"/>
             <a:r>
-              <a:rPr sz="1700" b="1" i="0">
+              <a:rPr sz="1800" b="1" i="0">
                 <a:solidFill>
                   <a:srgbClr val="FFFFFF"/>
                 </a:solidFill>
@@ -5067,7 +5067,7 @@
           <a:p>
             <a:pPr algn="ctr"/>
             <a:r>
-              <a:rPr sz="1700" b="1" i="0">
+              <a:rPr sz="1800" b="1" i="0">
                 <a:solidFill>
                   <a:srgbClr val="FFFFFF"/>
                 </a:solidFill>
@@ -5087,7 +5087,7 @@
         <p:spPr>
           <a:xfrm>
             <a:off x="6126480" y="5440680"/>
-            <a:ext cx="5486400" cy="274320"/>
+            <a:ext cx="5486400" cy="320040"/>
           </a:xfrm>
           <a:prstGeom prst="rect">
             <a:avLst/>
@@ -5102,13 +5102,13 @@
           <a:p>
             <a:pPr algn="l"/>
             <a:r>
-              <a:rPr sz="1200" b="0" i="1">
+              <a:rPr sz="1800" b="0" i="1">
                 <a:solidFill>
                   <a:srgbClr val="555B66"/>
                 </a:solidFill>
                 <a:latin typeface="Calibri"/>
               </a:rPr>
-              <a:t>Measured pipeline latency: median 204.7 ms per document (n = 200, CPU laptop)</a:t>
+              <a:t>Measured: median 204.7 ms per document (n = 200)</a:t>
             </a:r>
           </a:p>
         </p:txBody>
@@ -5137,13 +5137,13 @@
           <a:p>
             <a:pPr algn="l"/>
             <a:r>
-              <a:rPr sz="1100" b="0" i="0">
+              <a:rPr sz="1800" b="0" i="0">
                 <a:solidFill>
                   <a:srgbClr val="555B66"/>
                 </a:solidFill>
                 <a:latin typeface="Calibri"/>
               </a:rPr>
-              <a:t>Risk Signal Engine · Code to Connect 2026 · decision-support prototype, not investment advice</a:t>
+              <a:t>Risk Signal Engine · decision support, not investment advice</a:t>
             </a:r>
           </a:p>
         </p:txBody>
@@ -5172,7 +5172,7 @@
           <a:p>
             <a:pPr algn="r"/>
             <a:r>
-              <a:rPr sz="1100" b="0" i="0">
+              <a:rPr sz="1800" b="0" i="0">
                 <a:solidFill>
                   <a:srgbClr val="555B66"/>
                 </a:solidFill>
@@ -5287,8 +5287,8 @@
         </p:blipFill>
         <p:spPr>
           <a:xfrm>
-            <a:off x="1297615" y="1417320"/>
-            <a:ext cx="9596464" cy="4343400"/>
+            <a:off x="742030" y="1371600"/>
+            <a:ext cx="10707634" cy="4846320"/>
           </a:xfrm>
           <a:prstGeom prst="rect">
             <a:avLst/>
@@ -5302,14 +5302,14 @@
       </p:pic>
       <p:sp>
         <p:nvSpPr>
-          <p:cNvPr id="5" name="TextBox 4"/>
+          <p:cNvPr id="5" name="Footer"/>
           <p:cNvSpPr txBox="1"/>
           <p:nvPr/>
         </p:nvSpPr>
         <p:spPr>
           <a:xfrm>
-            <a:off x="1297615" y="5806440"/>
-            <a:ext cx="9596464" cy="274320"/>
+            <a:off x="548640" y="6446520"/>
+            <a:ext cx="8686800" cy="274320"/>
           </a:xfrm>
           <a:prstGeom prst="rect">
             <a:avLst/>
@@ -5324,27 +5324,27 @@
           <a:p>
             <a:pPr algn="l"/>
             <a:r>
-              <a:rPr sz="1200" b="0" i="1">
+              <a:rPr sz="1800" b="0" i="0">
                 <a:solidFill>
                   <a:srgbClr val="555B66"/>
                 </a:solidFill>
                 <a:latin typeface="Calibri"/>
               </a:rPr>
-              <a:t>Sources → ingestion → NLP → RiskSignal store and API → stress engine and dashboard · every record labelled LIVE / CACHED_REAL / SYNTHETIC (docs/architecture.png)</a:t>
-            </a:r>
-          </a:p>
-        </p:txBody>
-      </p:sp>
-      <p:sp>
-        <p:nvSpPr>
-          <p:cNvPr id="6" name="Footer"/>
+              <a:t>Risk Signal Engine · decision support, not investment advice</a:t>
+            </a:r>
+          </a:p>
+        </p:txBody>
+      </p:sp>
+      <p:sp>
+        <p:nvSpPr>
+          <p:cNvPr id="6" name="SlideNo"/>
           <p:cNvSpPr txBox="1"/>
           <p:nvPr/>
         </p:nvSpPr>
         <p:spPr>
           <a:xfrm>
-            <a:off x="548640" y="6446520"/>
-            <a:ext cx="8686800" cy="274320"/>
+            <a:off x="10911535" y="6446520"/>
+            <a:ext cx="731520" cy="274320"/>
           </a:xfrm>
           <a:prstGeom prst="rect">
             <a:avLst/>
@@ -5357,44 +5357,9 @@
           </a:bodyPr>
           <a:lstStyle/>
           <a:p>
-            <a:pPr algn="l"/>
-            <a:r>
-              <a:rPr sz="1100" b="0" i="0">
-                <a:solidFill>
-                  <a:srgbClr val="555B66"/>
-                </a:solidFill>
-                <a:latin typeface="Calibri"/>
-              </a:rPr>
-              <a:t>Risk Signal Engine · Code to Connect 2026 · decision-support prototype, not investment advice</a:t>
-            </a:r>
-          </a:p>
-        </p:txBody>
-      </p:sp>
-      <p:sp>
-        <p:nvSpPr>
-          <p:cNvPr id="7" name="SlideNo"/>
-          <p:cNvSpPr txBox="1"/>
-          <p:nvPr/>
-        </p:nvSpPr>
-        <p:spPr>
-          <a:xfrm>
-            <a:off x="10911535" y="6446520"/>
-            <a:ext cx="731520" cy="274320"/>
-          </a:xfrm>
-          <a:prstGeom prst="rect">
-            <a:avLst/>
-          </a:prstGeom>
-          <a:noFill/>
-        </p:spPr>
-        <p:txBody>
-          <a:bodyPr wrap="square" anchor="t" lIns="0" rIns="0" tIns="0" bIns="0">
-            <a:spAutoFit/>
-          </a:bodyPr>
-          <a:lstStyle/>
-          <a:p>
             <a:pPr algn="r"/>
             <a:r>
-              <a:rPr sz="1100" b="0" i="0">
+              <a:rPr sz="1800" b="0" i="0">
                 <a:solidFill>
                   <a:srgbClr val="555B66"/>
                 </a:solidFill>
@@ -5517,7 +5482,7 @@
           <a:p>
             <a:pPr marL="274320" indent="-274320">
               <a:spcAft>
-                <a:spcPts val="900"/>
+                <a:spcPts val="1600"/>
               </a:spcAft>
               <a:buClr>
                 <a:srgbClr val="0E8A84"/>
@@ -5526,7 +5491,7 @@
               <a:buChar char="•"/>
             </a:pPr>
             <a:r>
-              <a:rPr sz="1700" b="1" i="0">
+              <a:rPr sz="1800" b="1" i="0">
                 <a:solidFill>
                   <a:srgbClr val="1A1A1A"/>
                 </a:solidFill>
@@ -5535,19 +5500,19 @@
               <a:t>NLP: </a:t>
             </a:r>
             <a:r>
-              <a:rPr sz="1700" b="0" i="0">
+              <a:rPr sz="1800" b="0" i="0">
                 <a:solidFill>
                   <a:srgbClr val="1A1A1A"/>
                 </a:solidFill>
                 <a:latin typeface="Calibri"/>
               </a:rPr>
-              <a:t>entities (cashtags, aliases, spaCy, guarded fuzzy), FinBERT sentiment, 11-class event rules with evidence; optional fine-tuned models in a hybrid</a:t>
+              <a:t>entities, FinBERT sentiment, 11 event classes with evidence</a:t>
             </a:r>
           </a:p>
           <a:p>
             <a:pPr marL="274320" indent="-274320">
               <a:spcAft>
-                <a:spcPts val="900"/>
+                <a:spcPts val="1600"/>
               </a:spcAft>
               <a:buClr>
                 <a:srgbClr val="0E8A84"/>
@@ -5556,7 +5521,7 @@
               <a:buChar char="•"/>
             </a:pPr>
             <a:r>
-              <a:rPr sz="1700" b="1" i="0">
+              <a:rPr sz="1800" b="1" i="0">
                 <a:solidFill>
                   <a:srgbClr val="1A1A1A"/>
                 </a:solidFill>
@@ -5565,19 +5530,19 @@
               <a:t>Stress engine: </a:t>
             </a:r>
             <a:r>
-              <a:rPr sz="1700" b="0" i="0">
+              <a:rPr sz="1800" b="0" i="0">
                 <a:solidFill>
                   <a:srgbClr val="1A1A1A"/>
                 </a:solidFill>
                 <a:latin typeface="Calibri"/>
               </a:rPr>
-              <a:t>news-only systemic and issuer triggers with cooldown; pricers for bonds, loans, IRS, CDS, FX, equity; what-if sliders</a:t>
+              <a:t>news triggers with cooldown; bonds, loans, swaps, CDS, FX, equity</a:t>
             </a:r>
           </a:p>
           <a:p>
             <a:pPr marL="274320" indent="-274320">
               <a:spcAft>
-                <a:spcPts val="900"/>
+                <a:spcPts val="1600"/>
               </a:spcAft>
               <a:buClr>
                 <a:srgbClr val="0E8A84"/>
@@ -5586,7 +5551,7 @@
               <a:buChar char="•"/>
             </a:pPr>
             <a:r>
-              <a:rPr sz="1700" b="1" i="0">
+              <a:rPr sz="1800" b="1" i="0">
                 <a:solidFill>
                   <a:srgbClr val="1A1A1A"/>
                 </a:solidFill>
@@ -5595,19 +5560,19 @@
               <a:t>Credit views: </a:t>
             </a:r>
             <a:r>
-              <a:rPr sz="1700" b="0" i="0">
+              <a:rPr sz="1800" b="0" i="0">
                 <a:solidFill>
                   <a:srgbClr val="1A1A1A"/>
                 </a:solidFill>
                 <a:latin typeface="Calibri"/>
               </a:rPr>
-              <a:t>watchlist, propagation over 16 curated links, one-click credit brief</a:t>
+              <a:t>watchlist, propagation, one-click credit brief</a:t>
             </a:r>
           </a:p>
           <a:p>
             <a:pPr marL="274320" indent="-274320">
               <a:spcAft>
-                <a:spcPts val="900"/>
+                <a:spcPts val="1600"/>
               </a:spcAft>
               <a:buClr>
                 <a:srgbClr val="0E8A84"/>
@@ -5616,7 +5581,7 @@
               <a:buChar char="•"/>
             </a:pPr>
             <a:r>
-              <a:rPr sz="1700" b="1" i="0">
+              <a:rPr sz="1800" b="1" i="0">
                 <a:solidFill>
                   <a:srgbClr val="1A1A1A"/>
                 </a:solidFill>
@@ -5625,13 +5590,13 @@
               <a:t>Engineering: </a:t>
             </a:r>
             <a:r>
-              <a:rPr sz="1700" b="0" i="0">
+              <a:rPr sz="1800" b="0" i="0">
                 <a:solidFill>
                   <a:srgbClr val="1A1A1A"/>
                 </a:solidFill>
                 <a:latin typeface="Calibri"/>
               </a:rPr>
-              <a:t>one pipeline for every input, offline demo, time machine over real data, audit trail</a:t>
+              <a:t>one pipeline for every input, offline demo, time machine, audit trail</a:t>
             </a:r>
           </a:p>
         </p:txBody>
@@ -5674,7 +5639,7 @@
         <p:spPr>
           <a:xfrm>
             <a:off x="5623560" y="3106021"/>
-            <a:ext cx="6035040" cy="274320"/>
+            <a:ext cx="6035040" cy="320040"/>
           </a:xfrm>
           <a:prstGeom prst="rect">
             <a:avLst/>
@@ -5689,13 +5654,13 @@
           <a:p>
             <a:pPr algn="l"/>
             <a:r>
-              <a:rPr sz="1200" b="0" i="1">
+              <a:rPr sz="1800" b="0" i="1">
                 <a:solidFill>
                   <a:srgbClr val="555B66"/>
                 </a:solidFill>
                 <a:latin typeface="Calibri"/>
               </a:rPr>
-              <a:t>Dashboard explainability: factor contributions for a SYNTHETIC demo signal</a:t>
+              <a:t>Factor contributions for a SYNTHETIC demo signal</a:t>
             </a:r>
           </a:p>
         </p:txBody>
@@ -5708,8 +5673,8 @@
         </p:nvSpPr>
         <p:spPr>
           <a:xfrm>
-            <a:off x="5623560" y="3499213"/>
-            <a:ext cx="6035040" cy="1508760"/>
+            <a:off x="548640" y="4754880"/>
+            <a:ext cx="11094415" cy="1051560"/>
           </a:xfrm>
           <a:prstGeom prst="roundRect">
             <a:avLst>
@@ -5756,8 +5721,8 @@
         </p:nvSpPr>
         <p:spPr>
           <a:xfrm>
-            <a:off x="5852160" y="3636373"/>
-            <a:ext cx="5577840" cy="1280160"/>
+            <a:off x="822960" y="4910328"/>
+            <a:ext cx="10545775" cy="1005840"/>
           </a:xfrm>
           <a:prstGeom prst="rect">
             <a:avLst/>
@@ -5772,7 +5737,7 @@
           <a:p>
             <a:pPr algn="l"/>
             <a:r>
-              <a:rPr sz="1800" b="1" i="0">
+              <a:rPr sz="2400" b="1" i="0">
                 <a:solidFill>
                   <a:srgbClr val="1F2A44"/>
                 </a:solidFill>
@@ -5781,7 +5746,7 @@
               <a:t>Impact = 1 + 9 × Q × (</a:t>
             </a:r>
             <a:r>
-              <a:rPr sz="1800" b="1" i="0">
+              <a:rPr sz="2400" b="1" i="0">
                 <a:solidFill>
                   <a:srgbClr val="0E8A84"/>
                 </a:solidFill>
@@ -5790,7 +5755,7 @@
               <a:t>0.40·E + 0.25·M + 0.20·X + 0.15·R</a:t>
             </a:r>
             <a:r>
-              <a:rPr sz="1800" b="1" i="0">
+              <a:rPr sz="2400" b="1" i="0">
                 <a:solidFill>
                   <a:srgbClr val="1F2A44"/>
                 </a:solidFill>
@@ -5802,25 +5767,22 @@
           <a:p>
             <a:pPr algn="l"/>
             <a:r>
-              <a:rPr sz="1500" b="0" i="0">
+              <a:rPr sz="1800" b="0" i="0">
                 <a:solidFill>
                   <a:srgbClr val="1A1A1A"/>
                 </a:solidFill>
                 <a:latin typeface="Calibri"/>
               </a:rPr>
-              <a:t>E event severity · M sentiment magnitude · X exposure · R credibility + corroboration · Q confidence</a:t>
-            </a:r>
-          </a:p>
-          <a:p>
-            <a:pPr algn="l"/>
-            <a:r>
-              <a:rPr sz="1500" b="0" i="0">
+              <a:t>E severity · M sentiment · X exposure · R credibility · Q confidence · </a:t>
+            </a:r>
+            <a:r>
+              <a:rPr sz="1800" b="0" i="0">
                 <a:solidFill>
                   <a:srgbClr val="555B66"/>
                 </a:solidFill>
                 <a:latin typeface="Calibri"/>
               </a:rPr>
-              <a:t>Expert-set priors, not calibrated</a:t>
+              <a:t>uncalibrated expert priors</a:t>
             </a:r>
           </a:p>
         </p:txBody>
@@ -5849,13 +5811,13 @@
           <a:p>
             <a:pPr algn="l"/>
             <a:r>
-              <a:rPr sz="1100" b="0" i="0">
+              <a:rPr sz="1800" b="0" i="0">
                 <a:solidFill>
                   <a:srgbClr val="555B66"/>
                 </a:solidFill>
                 <a:latin typeface="Calibri"/>
               </a:rPr>
-              <a:t>Risk Signal Engine · Code to Connect 2026 · decision-support prototype, not investment advice</a:t>
+              <a:t>Risk Signal Engine · decision support, not investment advice</a:t>
             </a:r>
           </a:p>
         </p:txBody>
@@ -5884,7 +5846,7 @@
           <a:p>
             <a:pPr algn="r"/>
             <a:r>
-              <a:rPr sz="1100" b="0" i="0">
+              <a:rPr sz="1800" b="0" i="0">
                 <a:solidFill>
                   <a:srgbClr val="555B66"/>
                 </a:solidFill>
@@ -5992,7 +5954,7 @@
         <p:spPr>
           <a:xfrm>
             <a:off x="548640" y="1417320"/>
-            <a:ext cx="2103120" cy="1325880"/>
+            <a:ext cx="2103120" cy="1371600"/>
           </a:xfrm>
           <a:prstGeom prst="roundRect">
             <a:avLst>
@@ -6107,8 +6069,8 @@
         </p:nvSpPr>
         <p:spPr>
           <a:xfrm>
-            <a:off x="713232" y="2331720"/>
-            <a:ext cx="1828800" cy="320040"/>
+            <a:off x="713232" y="2359152"/>
+            <a:ext cx="1828800" cy="365760"/>
           </a:xfrm>
           <a:prstGeom prst="rect">
             <a:avLst/>
@@ -6123,13 +6085,13 @@
           <a:p>
             <a:pPr algn="l"/>
             <a:r>
-              <a:rPr sz="1200" b="0" i="0">
+              <a:rPr sz="1800" b="0" i="0">
                 <a:solidFill>
                   <a:srgbClr val="555B66"/>
                 </a:solidFill>
                 <a:latin typeface="Calibri"/>
               </a:rPr>
-              <a:t>accuracy · FinBERT · n = 147</a:t>
+              <a:t>FinBERT · n = 147</a:t>
             </a:r>
           </a:p>
         </p:txBody>
@@ -6143,7 +6105,7 @@
         <p:spPr>
           <a:xfrm>
             <a:off x="2770632" y="1417320"/>
-            <a:ext cx="2103120" cy="1325880"/>
+            <a:ext cx="2103120" cy="1371600"/>
           </a:xfrm>
           <a:prstGeom prst="roundRect">
             <a:avLst>
@@ -6258,8 +6220,8 @@
         </p:nvSpPr>
         <p:spPr>
           <a:xfrm>
-            <a:off x="2935224" y="2331720"/>
-            <a:ext cx="1828800" cy="320040"/>
+            <a:off x="2935224" y="2359152"/>
+            <a:ext cx="1828800" cy="365760"/>
           </a:xfrm>
           <a:prstGeom prst="rect">
             <a:avLst/>
@@ -6274,13 +6236,13 @@
           <a:p>
             <a:pPr algn="l"/>
             <a:r>
-              <a:rPr sz="1200" b="0" i="0">
+              <a:rPr sz="1800" b="0" i="0">
                 <a:solidFill>
                   <a:srgbClr val="555B66"/>
                 </a:solidFill>
                 <a:latin typeface="Calibri"/>
               </a:rPr>
-              <a:t>accuracy · rules · n = 147</a:t>
+              <a:t>rules · n = 147</a:t>
             </a:r>
           </a:p>
         </p:txBody>
@@ -6294,7 +6256,7 @@
         <p:spPr>
           <a:xfrm>
             <a:off x="4992624" y="1417320"/>
-            <a:ext cx="2103120" cy="1325880"/>
+            <a:ext cx="2103120" cy="1371600"/>
           </a:xfrm>
           <a:prstGeom prst="roundRect">
             <a:avLst>
@@ -6409,8 +6371,8 @@
         </p:nvSpPr>
         <p:spPr>
           <a:xfrm>
-            <a:off x="5157216" y="2331720"/>
-            <a:ext cx="1828800" cy="320040"/>
+            <a:off x="5157216" y="2359152"/>
+            <a:ext cx="1828800" cy="365760"/>
           </a:xfrm>
           <a:prstGeom prst="rect">
             <a:avLst/>
@@ -6425,13 +6387,13 @@
           <a:p>
             <a:pPr algn="l"/>
             <a:r>
-              <a:rPr sz="1200" b="0" i="0">
+              <a:rPr sz="1800" b="0" i="0">
                 <a:solidFill>
                   <a:srgbClr val="555B66"/>
                 </a:solidFill>
                 <a:latin typeface="Calibri"/>
               </a:rPr>
-              <a:t>accuracy · n = 147</a:t>
+              <a:t>n = 147</a:t>
             </a:r>
           </a:p>
         </p:txBody>
@@ -6445,7 +6407,7 @@
         <p:spPr>
           <a:xfrm>
             <a:off x="7214616" y="1417320"/>
-            <a:ext cx="2103120" cy="1325880"/>
+            <a:ext cx="2103120" cy="1371600"/>
           </a:xfrm>
           <a:prstGeom prst="roundRect">
             <a:avLst>
@@ -6560,8 +6522,8 @@
         </p:nvSpPr>
         <p:spPr>
           <a:xfrm>
-            <a:off x="7379208" y="2331720"/>
-            <a:ext cx="1828800" cy="320040"/>
+            <a:off x="7379208" y="2359152"/>
+            <a:ext cx="1828800" cy="365760"/>
           </a:xfrm>
           <a:prstGeom prst="rect">
             <a:avLst/>
@@ -6576,13 +6538,13 @@
           <a:p>
             <a:pPr algn="l"/>
             <a:r>
-              <a:rPr sz="1200" b="0" i="0">
+              <a:rPr sz="1800" b="0" i="0">
                 <a:solidFill>
                   <a:srgbClr val="555B66"/>
                 </a:solidFill>
                 <a:latin typeface="Calibri"/>
               </a:rPr>
-              <a:t>p95 1085.2 ms · n = 200</a:t>
+              <a:t>n = 200 docs</a:t>
             </a:r>
           </a:p>
         </p:txBody>
@@ -6596,7 +6558,7 @@
         <p:spPr>
           <a:xfrm>
             <a:off x="9436608" y="1417320"/>
-            <a:ext cx="2103120" cy="1325880"/>
+            <a:ext cx="2103120" cy="1371600"/>
           </a:xfrm>
           <a:prstGeom prst="roundRect">
             <a:avLst>
@@ -6711,8 +6673,8 @@
         </p:nvSpPr>
         <p:spPr>
           <a:xfrm>
-            <a:off x="9601200" y="2331720"/>
-            <a:ext cx="1828800" cy="320040"/>
+            <a:off x="9601200" y="2359152"/>
+            <a:ext cx="1828800" cy="365760"/>
           </a:xfrm>
           <a:prstGeom prst="rect">
             <a:avLst/>
@@ -6727,13 +6689,13 @@
           <a:p>
             <a:pPr algn="l"/>
             <a:r>
-              <a:rPr sz="1200" b="0" i="0">
+              <a:rPr sz="1800" b="0" i="0">
                 <a:solidFill>
                   <a:srgbClr val="555B66"/>
                 </a:solidFill>
                 <a:latin typeface="Calibri"/>
               </a:rPr>
-              <a:t>replay after fixes · n = 911</a:t>
+              <a:t>n = 911 real docs</a:t>
             </a:r>
           </a:p>
         </p:txBody>
@@ -6746,8 +6708,8 @@
         </p:nvSpPr>
         <p:spPr>
           <a:xfrm>
-            <a:off x="548640" y="2788920"/>
-            <a:ext cx="10972800" cy="274320"/>
+            <a:off x="548640" y="2834640"/>
+            <a:ext cx="10972800" cy="320040"/>
           </a:xfrm>
           <a:prstGeom prst="rect">
             <a:avLst/>
@@ -6762,13 +6724,13 @@
           <a:p>
             <a:pPr algn="l"/>
             <a:r>
-              <a:rPr sz="1200" b="0" i="1">
+              <a:rPr sz="1800" b="0" i="1">
                 <a:solidFill>
                   <a:srgbClr val="555B66"/>
                 </a:solidFill>
                 <a:latin typeface="Calibri"/>
               </a:rPr>
-              <a:t>Preliminary (labels pending human review): labels drafted by an AI assistant, which also wrote the event rules. Treat as a smoke test, not a benchmark.</a:t>
+              <a:t>AI-drafted labels: a smoke test, not a benchmark.</a:t>
             </a:r>
           </a:p>
         </p:txBody>
@@ -6781,7 +6743,7 @@
         </p:nvSpPr>
         <p:spPr>
           <a:xfrm>
-            <a:off x="548640" y="3246120"/>
+            <a:off x="548640" y="3291839"/>
             <a:ext cx="4480560" cy="365760"/>
           </a:xfrm>
           <a:prstGeom prst="rect">
@@ -6816,7 +6778,7 @@
         </p:nvSpPr>
         <p:spPr>
           <a:xfrm>
-            <a:off x="548640" y="3794760"/>
+            <a:off x="548640" y="3840479"/>
             <a:ext cx="237744" cy="237744"/>
           </a:xfrm>
           <a:prstGeom prst="ellipse">
@@ -6860,7 +6822,7 @@
         </p:nvSpPr>
         <p:spPr>
           <a:xfrm>
-            <a:off x="932688" y="3703320"/>
+            <a:off x="932688" y="3749039"/>
             <a:ext cx="4023360" cy="420624"/>
           </a:xfrm>
           <a:prstGeom prst="rect">
@@ -6885,7 +6847,7 @@
               <a:t>0.41% GREEN  </a:t>
             </a:r>
             <a:r>
-              <a:rPr sz="1700" b="0" i="0">
+              <a:rPr sz="1800" b="0" i="0">
                 <a:solidFill>
                   <a:srgbClr val="1A1A1A"/>
                 </a:solidFill>
@@ -6904,7 +6866,7 @@
         </p:nvSpPr>
         <p:spPr>
           <a:xfrm>
-            <a:off x="548640" y="4251960"/>
+            <a:off x="548640" y="4297679"/>
             <a:ext cx="237744" cy="237744"/>
           </a:xfrm>
           <a:prstGeom prst="ellipse">
@@ -6948,7 +6910,7 @@
         </p:nvSpPr>
         <p:spPr>
           <a:xfrm>
-            <a:off x="932688" y="4160520"/>
+            <a:off x="932688" y="4206239"/>
             <a:ext cx="4023360" cy="420624"/>
           </a:xfrm>
           <a:prstGeom prst="rect">
@@ -6973,7 +6935,7 @@
               <a:t>1.32% AMBER  </a:t>
             </a:r>
             <a:r>
-              <a:rPr sz="1700" b="0" i="0">
+              <a:rPr sz="1800" b="0" i="0">
                 <a:solidFill>
                   <a:srgbClr val="1A1A1A"/>
                 </a:solidFill>
@@ -6992,7 +6954,7 @@
         </p:nvSpPr>
         <p:spPr>
           <a:xfrm>
-            <a:off x="548640" y="4709160"/>
+            <a:off x="548640" y="4754879"/>
             <a:ext cx="237744" cy="237744"/>
           </a:xfrm>
           <a:prstGeom prst="ellipse">
@@ -7036,7 +6998,7 @@
         </p:nvSpPr>
         <p:spPr>
           <a:xfrm>
-            <a:off x="932688" y="4617720"/>
+            <a:off x="932688" y="4663439"/>
             <a:ext cx="4023360" cy="420624"/>
           </a:xfrm>
           <a:prstGeom prst="rect">
@@ -7061,7 +7023,7 @@
               <a:t>2.45% RED  </a:t>
             </a:r>
             <a:r>
-              <a:rPr sz="1700" b="0" i="0">
+              <a:rPr sz="1800" b="0" i="0">
                 <a:solidFill>
                   <a:srgbClr val="1A1A1A"/>
                 </a:solidFill>
@@ -7080,8 +7042,8 @@
         </p:nvSpPr>
         <p:spPr>
           <a:xfrm>
-            <a:off x="548640" y="5212080"/>
-            <a:ext cx="4480560" cy="1097280"/>
+            <a:off x="548640" y="5212079"/>
+            <a:ext cx="4480560" cy="731520"/>
           </a:xfrm>
           <a:prstGeom prst="rect">
             <a:avLst/>
@@ -7096,7 +7058,7 @@
           <a:p>
             <a:pPr algn="l"/>
             <a:r>
-              <a:rPr sz="1600" b="1" i="0">
+              <a:rPr sz="1800" b="1" i="0">
                 <a:solidFill>
                   <a:srgbClr val="1F2A44"/>
                 </a:solidFill>
@@ -7105,55 +7067,20 @@
               <a:t>REAL history: </a:t>
             </a:r>
             <a:r>
-              <a:rPr sz="1600" b="0" i="0">
+              <a:rPr sz="1800" b="0" i="0">
                 <a:solidFill>
                   <a:srgbClr val="1A1A1A"/>
                 </a:solidFill>
                 <a:latin typeface="Calibri"/>
               </a:rPr>
-              <a:t>1,325 captured documents → 1,325 signals → 54 simulated stress runs</a:t>
-            </a:r>
-          </a:p>
-        </p:txBody>
-      </p:sp>
-      <p:sp>
-        <p:nvSpPr>
-          <p:cNvPr id="33" name="TextBox 32"/>
-          <p:cNvSpPr txBox="1"/>
-          <p:nvPr/>
-        </p:nvSpPr>
-        <p:spPr>
-          <a:xfrm>
-            <a:off x="548640" y="5897880"/>
-            <a:ext cx="4480560" cy="457200"/>
-          </a:xfrm>
-          <a:prstGeom prst="rect">
-            <a:avLst/>
-          </a:prstGeom>
-          <a:noFill/>
-        </p:spPr>
-        <p:txBody>
-          <a:bodyPr wrap="square" anchor="t" lIns="0" rIns="0" tIns="0" bIns="0">
-            <a:spAutoFit/>
-          </a:bodyPr>
-          <a:lstStyle/>
-          <a:p>
-            <a:pPr algn="l"/>
-            <a:r>
-              <a:rPr sz="1200" b="1" i="0">
-                <a:solidFill>
-                  <a:srgbClr val="D03B3B"/>
-                </a:solidFill>
-                <a:latin typeface="Calibri"/>
-              </a:rPr>
-              <a:t>Simplified, illustrative hackathon stress model. Not a production or regulatory risk model.</a:t>
+              <a:t>1,325 docs → 54 simulated runs</a:t>
             </a:r>
           </a:p>
         </p:txBody>
       </p:sp>
       <p:pic>
         <p:nvPicPr>
-          <p:cNvPr id="34" name="Picture 33" descr="stress_waterfall.png"/>
+          <p:cNvPr id="33" name="Picture 32" descr="stress_waterfall.png"/>
           <p:cNvPicPr>
             <a:picLocks noChangeAspect="1"/>
           </p:cNvPicPr>
@@ -7167,7 +7094,7 @@
         </p:blipFill>
         <p:spPr>
           <a:xfrm>
-            <a:off x="5120640" y="3246120"/>
+            <a:off x="5120640" y="3291839"/>
             <a:ext cx="6537960" cy="2451735"/>
           </a:xfrm>
           <a:prstGeom prst="rect">
@@ -7182,14 +7109,14 @@
       </p:pic>
       <p:sp>
         <p:nvSpPr>
-          <p:cNvPr id="35" name="TextBox 34"/>
+          <p:cNvPr id="34" name="TextBox 33"/>
           <p:cNvSpPr txBox="1"/>
           <p:nvPr/>
         </p:nvSpPr>
         <p:spPr>
           <a:xfrm>
-            <a:off x="5120640" y="5725287"/>
-            <a:ext cx="6537960" cy="274320"/>
+            <a:off x="5120640" y="5771006"/>
+            <a:ext cx="6537960" cy="320040"/>
           </a:xfrm>
           <a:prstGeom prst="rect">
             <a:avLst/>
@@ -7204,27 +7131,27 @@
           <a:p>
             <a:pPr algn="l"/>
             <a:r>
-              <a:rPr sz="1200" b="0" i="1">
+              <a:rPr sz="1800" b="0" i="1">
                 <a:solidFill>
                   <a:srgbClr val="555B66"/>
                 </a:solidFill>
                 <a:latin typeface="Calibri"/>
               </a:rPr>
-              <a:t>Before → after, corroborated geopolitical shock · Illustrative model, synthetic portfolio</a:t>
-            </a:r>
-          </a:p>
-        </p:txBody>
-      </p:sp>
-      <p:sp>
-        <p:nvSpPr>
-          <p:cNvPr id="36" name="Footer"/>
+              <a:t>Before → after, corroborated geopolitical shock</a:t>
+            </a:r>
+          </a:p>
+        </p:txBody>
+      </p:sp>
+      <p:sp>
+        <p:nvSpPr>
+          <p:cNvPr id="35" name="Disclaimer"/>
           <p:cNvSpPr txBox="1"/>
           <p:nvPr/>
         </p:nvSpPr>
         <p:spPr>
           <a:xfrm>
-            <a:off x="548640" y="6446520"/>
-            <a:ext cx="8686800" cy="274320"/>
+            <a:off x="548640" y="6080760"/>
+            <a:ext cx="11094415" cy="320040"/>
           </a:xfrm>
           <a:prstGeom prst="rect">
             <a:avLst/>
@@ -7239,27 +7166,27 @@
           <a:p>
             <a:pPr algn="l"/>
             <a:r>
-              <a:rPr sz="1100" b="0" i="0">
-                <a:solidFill>
-                  <a:srgbClr val="555B66"/>
-                </a:solidFill>
-                <a:latin typeface="Calibri"/>
-              </a:rPr>
-              <a:t>Demo losses: simulated, illustrative model, synthetic portfolio · not investment advice</a:t>
-            </a:r>
-          </a:p>
-        </p:txBody>
-      </p:sp>
-      <p:sp>
-        <p:nvSpPr>
-          <p:cNvPr id="37" name="SlideNo"/>
+              <a:rPr sz="1800" b="1" i="0">
+                <a:solidFill>
+                  <a:srgbClr val="D03B3B"/>
+                </a:solidFill>
+                <a:latin typeface="Calibri"/>
+              </a:rPr>
+              <a:t>Simplified, illustrative hackathon stress model. Not a production or regulatory risk model.</a:t>
+            </a:r>
+          </a:p>
+        </p:txBody>
+      </p:sp>
+      <p:sp>
+        <p:nvSpPr>
+          <p:cNvPr id="36" name="Footer"/>
           <p:cNvSpPr txBox="1"/>
           <p:nvPr/>
         </p:nvSpPr>
         <p:spPr>
           <a:xfrm>
-            <a:off x="10911535" y="6446520"/>
-            <a:ext cx="731520" cy="274320"/>
+            <a:off x="548640" y="6446520"/>
+            <a:ext cx="8686800" cy="274320"/>
           </a:xfrm>
           <a:prstGeom prst="rect">
             <a:avLst/>
@@ -7272,9 +7199,44 @@
           </a:bodyPr>
           <a:lstStyle/>
           <a:p>
+            <a:pPr algn="l"/>
+            <a:r>
+              <a:rPr sz="1800" b="0" i="0">
+                <a:solidFill>
+                  <a:srgbClr val="555B66"/>
+                </a:solidFill>
+                <a:latin typeface="Calibri"/>
+              </a:rPr>
+              <a:t>Simulated losses · illustrative model, synthetic portfolio · not investment advice</a:t>
+            </a:r>
+          </a:p>
+        </p:txBody>
+      </p:sp>
+      <p:sp>
+        <p:nvSpPr>
+          <p:cNvPr id="37" name="SlideNo"/>
+          <p:cNvSpPr txBox="1"/>
+          <p:nvPr/>
+        </p:nvSpPr>
+        <p:spPr>
+          <a:xfrm>
+            <a:off x="10911535" y="6446520"/>
+            <a:ext cx="731520" cy="274320"/>
+          </a:xfrm>
+          <a:prstGeom prst="rect">
+            <a:avLst/>
+          </a:prstGeom>
+          <a:noFill/>
+        </p:spPr>
+        <p:txBody>
+          <a:bodyPr wrap="square" anchor="t" lIns="0" rIns="0" tIns="0" bIns="0">
+            <a:spAutoFit/>
+          </a:bodyPr>
+          <a:lstStyle/>
+          <a:p>
             <a:pPr algn="r"/>
             <a:r>
-              <a:rPr sz="1100" b="0" i="0">
+              <a:rPr sz="1800" b="0" i="0">
                 <a:solidFill>
                   <a:srgbClr val="555B66"/>
                 </a:solidFill>
@@ -7382,7 +7344,7 @@
         <p:spPr>
           <a:xfrm>
             <a:off x="548640" y="1417320"/>
-            <a:ext cx="3611880" cy="1188720"/>
+            <a:ext cx="3611880" cy="1280160"/>
           </a:xfrm>
           <a:prstGeom prst="roundRect">
             <a:avLst>
@@ -7462,8 +7424,8 @@
         </p:nvSpPr>
         <p:spPr>
           <a:xfrm>
-            <a:off x="731520" y="1920240"/>
-            <a:ext cx="3291840" cy="640080"/>
+            <a:off x="731520" y="1892808"/>
+            <a:ext cx="3291840" cy="731520"/>
           </a:xfrm>
           <a:prstGeom prst="rect">
             <a:avLst/>
@@ -7478,13 +7440,13 @@
           <a:p>
             <a:pPr algn="l"/>
             <a:r>
-              <a:rPr sz="1500" b="0" i="0">
+              <a:rPr sz="1800" b="0" i="0">
                 <a:solidFill>
                   <a:srgbClr val="1A1A1A"/>
                 </a:solidFill>
                 <a:latin typeface="Calibri"/>
               </a:rPr>
-              <a:t>see which held names need attention and the rule that fired</a:t>
+              <a:t>see which held names need attention, and why</a:t>
             </a:r>
           </a:p>
         </p:txBody>
@@ -7498,7 +7460,7 @@
         <p:spPr>
           <a:xfrm>
             <a:off x="4270248" y="1417320"/>
-            <a:ext cx="3611880" cy="1188720"/>
+            <a:ext cx="3611880" cy="1280160"/>
           </a:xfrm>
           <a:prstGeom prst="roundRect">
             <a:avLst>
@@ -7578,8 +7540,8 @@
         </p:nvSpPr>
         <p:spPr>
           <a:xfrm>
-            <a:off x="4453128" y="1920240"/>
-            <a:ext cx="3291840" cy="640080"/>
+            <a:off x="4453128" y="1892808"/>
+            <a:ext cx="3291840" cy="731520"/>
           </a:xfrm>
           <a:prstGeom prst="rect">
             <a:avLst/>
@@ -7594,13 +7556,13 @@
           <a:p>
             <a:pPr algn="l"/>
             <a:r>
-              <a:rPr sz="1500" b="0" i="0">
+              <a:rPr sz="1800" b="0" i="0">
                 <a:solidFill>
                   <a:srgbClr val="1A1A1A"/>
                 </a:solidFill>
                 <a:latin typeface="Calibri"/>
               </a:rPr>
-              <a:t>get an audited, simulated portfolio view when news breaks</a:t>
+              <a:t>get an audited portfolio view when news breaks</a:t>
             </a:r>
           </a:p>
         </p:txBody>
@@ -7614,7 +7576,7 @@
         <p:spPr>
           <a:xfrm>
             <a:off x="7991856" y="1417320"/>
-            <a:ext cx="3611880" cy="1188720"/>
+            <a:ext cx="3611880" cy="1280160"/>
           </a:xfrm>
           <a:prstGeom prst="roundRect">
             <a:avLst>
@@ -7694,8 +7656,8 @@
         </p:nvSpPr>
         <p:spPr>
           <a:xfrm>
-            <a:off x="8174736" y="1920240"/>
-            <a:ext cx="3291840" cy="640080"/>
+            <a:off x="8174736" y="1892808"/>
+            <a:ext cx="3291840" cy="731520"/>
           </a:xfrm>
           <a:prstGeom prst="rect">
             <a:avLst/>
@@ -7710,13 +7672,13 @@
           <a:p>
             <a:pPr algn="l"/>
             <a:r>
-              <a:rPr sz="1500" b="0" i="0">
+              <a:rPr sz="1800" b="0" i="0">
                 <a:solidFill>
                   <a:srgbClr val="1A1A1A"/>
                 </a:solidFill>
                 <a:latin typeface="Calibri"/>
               </a:rPr>
-              <a:t>see linked exposure and test their own shocks instantly</a:t>
+              <a:t>see linked exposure and test their own shocks</a:t>
             </a:r>
           </a:p>
         </p:txBody>
@@ -7737,8 +7699,8 @@
         </p:blipFill>
         <p:spPr>
           <a:xfrm>
-            <a:off x="548640" y="2834640"/>
-            <a:ext cx="3840480" cy="2057400"/>
+            <a:off x="548640" y="2880360"/>
+            <a:ext cx="3755136" cy="2011680"/>
           </a:xfrm>
           <a:prstGeom prst="rect">
             <a:avLst/>
@@ -7766,8 +7728,8 @@
         </p:blipFill>
         <p:spPr>
           <a:xfrm>
-            <a:off x="4526280" y="2834640"/>
-            <a:ext cx="3923756" cy="2057400"/>
+            <a:off x="4440936" y="2880360"/>
+            <a:ext cx="3836561" cy="2011680"/>
           </a:xfrm>
           <a:prstGeom prst="rect">
             <a:avLst/>
@@ -7795,8 +7757,8 @@
         </p:blipFill>
         <p:spPr>
           <a:xfrm>
-            <a:off x="8587196" y="2834640"/>
-            <a:ext cx="3055859" cy="2218327"/>
+            <a:off x="8414657" y="2880360"/>
+            <a:ext cx="2771192" cy="2011680"/>
           </a:xfrm>
           <a:prstGeom prst="rect">
             <a:avLst/>
@@ -7817,7 +7779,7 @@
         <p:spPr>
           <a:xfrm>
             <a:off x="548640" y="4928616"/>
-            <a:ext cx="3840480" cy="274320"/>
+            <a:ext cx="3755136" cy="320040"/>
           </a:xfrm>
           <a:prstGeom prst="rect">
             <a:avLst/>
@@ -7832,13 +7794,13 @@
           <a:p>
             <a:pPr algn="l"/>
             <a:r>
-              <a:rPr sz="1200" b="0" i="1">
+              <a:rPr sz="1800" b="0" i="1">
                 <a:solidFill>
                   <a:srgbClr val="555B66"/>
                 </a:solidFill>
                 <a:latin typeface="Calibri"/>
               </a:rPr>
-              <a:t>Early-warning watchlist on real news</a:t>
+              <a:t>Watchlist on real news</a:t>
             </a:r>
           </a:p>
         </p:txBody>
@@ -7851,8 +7813,8 @@
         </p:nvSpPr>
         <p:spPr>
           <a:xfrm>
-            <a:off x="4526280" y="4928616"/>
-            <a:ext cx="3923756" cy="274320"/>
+            <a:off x="4440936" y="4928616"/>
+            <a:ext cx="3836561" cy="320040"/>
           </a:xfrm>
           <a:prstGeom prst="rect">
             <a:avLst/>
@@ -7867,13 +7829,13 @@
           <a:p>
             <a:pPr algn="l"/>
             <a:r>
-              <a:rPr sz="1200" b="0" i="1">
+              <a:rPr sz="1800" b="0" i="1">
                 <a:solidFill>
                   <a:srgbClr val="555B66"/>
                 </a:solidFill>
                 <a:latin typeface="Calibri"/>
               </a:rPr>
-              <a:t>One-click credit brief (template, no LLM; PDF)</a:t>
+              <a:t>Credit brief (PDF)</a:t>
             </a:r>
           </a:p>
         </p:txBody>
@@ -7886,8 +7848,8 @@
         </p:nvSpPr>
         <p:spPr>
           <a:xfrm>
-            <a:off x="8587196" y="5089543"/>
-            <a:ext cx="3055859" cy="274320"/>
+            <a:off x="8414657" y="4928616"/>
+            <a:ext cx="2771192" cy="320040"/>
           </a:xfrm>
           <a:prstGeom prst="rect">
             <a:avLst/>
@@ -7902,20 +7864,101 @@
           <a:p>
             <a:pPr algn="l"/>
             <a:r>
-              <a:rPr sz="1200" b="0" i="1">
+              <a:rPr sz="1800" b="0" i="1">
                 <a:solidFill>
                   <a:srgbClr val="555B66"/>
                 </a:solidFill>
                 <a:latin typeface="Calibri"/>
               </a:rPr>
-              <a:t>Propagation over curated links</a:t>
-            </a:r>
-          </a:p>
-        </p:txBody>
-      </p:sp>
-      <p:sp>
-        <p:nvSpPr>
-          <p:cNvPr id="19" name="Footer"/>
+              <a:t>Propagation graph</a:t>
+            </a:r>
+          </a:p>
+        </p:txBody>
+      </p:sp>
+      <p:sp>
+        <p:nvSpPr>
+          <p:cNvPr id="19" name="Rounded Rectangle 18"/>
+          <p:cNvSpPr/>
+          <p:nvPr/>
+        </p:nvSpPr>
+        <p:spPr>
+          <a:xfrm>
+            <a:off x="548640" y="5440680"/>
+            <a:ext cx="11094415" cy="777240"/>
+          </a:xfrm>
+          <a:prstGeom prst="roundRect">
+            <a:avLst>
+              <a:gd name="adj" fmla="val 6000"/>
+            </a:avLst>
+          </a:prstGeom>
+          <a:solidFill>
+            <a:srgbClr val="1F2A44"/>
+          </a:solidFill>
+          <a:ln>
+            <a:noFill/>
+          </a:ln>
+          <a:effectLst/>
+        </p:spPr>
+        <p:style>
+          <a:lnRef idx="1">
+            <a:schemeClr val="accent1"/>
+          </a:lnRef>
+          <a:fillRef idx="3">
+            <a:schemeClr val="accent1"/>
+          </a:fillRef>
+          <a:effectRef idx="2">
+            <a:schemeClr val="accent1"/>
+          </a:effectRef>
+          <a:fontRef idx="minor">
+            <a:schemeClr val="lt1"/>
+          </a:fontRef>
+        </p:style>
+        <p:txBody>
+          <a:bodyPr rtlCol="0" anchor="ctr"/>
+          <a:lstStyle/>
+          <a:p>
+            <a:pPr algn="ctr"/>
+          </a:p>
+        </p:txBody>
+      </p:sp>
+      <p:sp>
+        <p:nvSpPr>
+          <p:cNvPr id="20" name="TextBox 19"/>
+          <p:cNvSpPr txBox="1"/>
+          <p:nvPr/>
+        </p:nvSpPr>
+        <p:spPr>
+          <a:xfrm>
+            <a:off x="914400" y="5440680"/>
+            <a:ext cx="10362895" cy="777240"/>
+          </a:xfrm>
+          <a:prstGeom prst="rect">
+            <a:avLst/>
+          </a:prstGeom>
+          <a:noFill/>
+        </p:spPr>
+        <p:txBody>
+          <a:bodyPr wrap="square" anchor="ctr" lIns="0" rIns="0" tIns="0" bIns="0">
+            <a:spAutoFit/>
+          </a:bodyPr>
+          <a:lstStyle/>
+          <a:p>
+            <a:pPr algn="l"/>
+            <a:r>
+              <a:rPr sz="2200" b="1" i="0">
+                <a:solidFill>
+                  <a:srgbClr val="FFFFFF"/>
+                </a:solidFill>
+                <a:latin typeface="Calibri"/>
+              </a:rPr>
+              <a:t>No ROI claims: earlier attention, triage with the reason shown, audit trail to the headline</a:t>
+            </a:r>
+          </a:p>
+        </p:txBody>
+      </p:sp>
+      <p:sp>
+        <p:nvSpPr>
+          <p:cNvPr id="21" name="Footer"/>
           <p:cNvSpPr txBox="1"/>
           <p:nvPr/>
         </p:nvSpPr>
@@ -7937,20 +7980,20 @@
           <a:p>
             <a:pPr algn="l"/>
             <a:r>
-              <a:rPr sz="1100" b="0" i="0">
+              <a:rPr sz="1800" b="0" i="0">
                 <a:solidFill>
                   <a:srgbClr val="555B66"/>
                 </a:solidFill>
                 <a:latin typeface="Calibri"/>
               </a:rPr>
-              <a:t>Risk Signal Engine · Code to Connect 2026 · decision-support prototype, not investment advice</a:t>
-            </a:r>
-          </a:p>
-        </p:txBody>
-      </p:sp>
-      <p:sp>
-        <p:nvSpPr>
-          <p:cNvPr id="20" name="SlideNo"/>
+              <a:t>Risk Signal Engine · decision support, not investment advice</a:t>
+            </a:r>
+          </a:p>
+        </p:txBody>
+      </p:sp>
+      <p:sp>
+        <p:nvSpPr>
+          <p:cNvPr id="22" name="SlideNo"/>
           <p:cNvSpPr txBox="1"/>
           <p:nvPr/>
         </p:nvSpPr>
@@ -7972,7 +8015,7 @@
           <a:p>
             <a:pPr algn="r"/>
             <a:r>
-              <a:rPr sz="1100" b="0" i="0">
+              <a:rPr sz="1800" b="0" i="0">
                 <a:solidFill>
                   <a:srgbClr val="555B66"/>
                 </a:solidFill>
@@ -8045,7 +8088,7 @@
         <p:spPr>
           <a:xfrm>
             <a:off x="548640" y="1188720"/>
-            <a:ext cx="3566160" cy="3611880"/>
+            <a:ext cx="3566160" cy="3429000"/>
           </a:xfrm>
           <a:prstGeom prst="roundRect">
             <a:avLst>
@@ -8125,8 +8168,8 @@
         </p:nvSpPr>
         <p:spPr>
           <a:xfrm>
-            <a:off x="822960" y="1920240"/>
-            <a:ext cx="3063240" cy="2743200"/>
+            <a:off x="822960" y="1965960"/>
+            <a:ext cx="3063240" cy="2651760"/>
           </a:xfrm>
           <a:prstGeom prst="rect">
             <a:avLst/>
@@ -8141,7 +8184,7 @@
           <a:p>
             <a:pPr marL="274320" indent="-274320">
               <a:spcAft>
-                <a:spcPts val="600"/>
+                <a:spcPts val="1400"/>
               </a:spcAft>
               <a:buClr>
                 <a:srgbClr val="0E8A84"/>
@@ -8150,19 +8193,19 @@
               <a:buChar char="•"/>
             </a:pPr>
             <a:r>
-              <a:rPr sz="1700" b="0" i="0">
+              <a:rPr sz="1800" b="0" i="0">
                 <a:solidFill>
                   <a:srgbClr val="1A1A1A"/>
                 </a:solidFill>
                 <a:latin typeface="Calibri"/>
               </a:rPr>
-              <a:t>Impact weights are uncalibrated priors</a:t>
+              <a:t>Uncalibrated impact weights</a:t>
             </a:r>
           </a:p>
           <a:p>
             <a:pPr marL="274320" indent="-274320">
               <a:spcAft>
-                <a:spcPts val="600"/>
+                <a:spcPts val="1400"/>
               </a:spcAft>
               <a:buClr>
                 <a:srgbClr val="0E8A84"/>
@@ -8171,19 +8214,19 @@
               <a:buChar char="•"/>
             </a:pPr>
             <a:r>
-              <a:rPr sz="1700" b="0" i="0">
+              <a:rPr sz="1800" b="0" i="0">
                 <a:solidFill>
                   <a:srgbClr val="1A1A1A"/>
                 </a:solidFill>
                 <a:latin typeface="Calibri"/>
               </a:rPr>
-              <a:t>Keyword rules still misfire on real data</a:t>
+              <a:t>Rules still misfire at times</a:t>
             </a:r>
           </a:p>
           <a:p>
             <a:pPr marL="274320" indent="-274320">
               <a:spcAft>
-                <a:spcPts val="600"/>
+                <a:spcPts val="1400"/>
               </a:spcAft>
               <a:buClr>
                 <a:srgbClr val="0E8A84"/>
@@ -8192,19 +8235,19 @@
               <a:buChar char="•"/>
             </a:pPr>
             <a:r>
-              <a:rPr sz="1700" b="0" i="0">
+              <a:rPr sz="1800" b="0" i="0">
                 <a:solidFill>
                   <a:srgbClr val="1A1A1A"/>
                 </a:solidFill>
                 <a:latin typeface="Calibri"/>
               </a:rPr>
-              <a:t>Headline-only news text</a:t>
+              <a:t>Headline-only news</a:t>
             </a:r>
           </a:p>
           <a:p>
             <a:pPr marL="274320" indent="-274320">
               <a:spcAft>
-                <a:spcPts val="600"/>
+                <a:spcPts val="1400"/>
               </a:spcAft>
               <a:buClr>
                 <a:srgbClr val="0E8A84"/>
@@ -8213,19 +8256,19 @@
               <a:buChar char="•"/>
             </a:pPr>
             <a:r>
-              <a:rPr sz="1700" b="0" i="0">
+              <a:rPr sz="1800" b="0" i="0">
                 <a:solidFill>
                   <a:srgbClr val="1A1A1A"/>
                 </a:solidFill>
                 <a:latin typeface="Calibri"/>
               </a:rPr>
-              <a:t>Small AI-labelled evaluation set</a:t>
+              <a:t>Small AI-labelled eval set</a:t>
             </a:r>
           </a:p>
           <a:p>
             <a:pPr marL="274320" indent="-274320">
               <a:spcAft>
-                <a:spcPts val="600"/>
+                <a:spcPts val="1400"/>
               </a:spcAft>
               <a:buClr>
                 <a:srgbClr val="0E8A84"/>
@@ -8234,13 +8277,13 @@
               <a:buChar char="•"/>
             </a:pPr>
             <a:r>
-              <a:rPr sz="1700" b="0" i="0">
+              <a:rPr sz="1800" b="0" i="0">
                 <a:solidFill>
                   <a:srgbClr val="1A1A1A"/>
                 </a:solidFill>
                 <a:latin typeface="Calibri"/>
               </a:rPr>
-              <a:t>Illustrative stress model, synthetic portfolio</a:t>
+              <a:t>Illustrative stress model</a:t>
             </a:r>
           </a:p>
         </p:txBody>
@@ -8254,7 +8297,7 @@
         <p:spPr>
           <a:xfrm>
             <a:off x="4270248" y="1188720"/>
-            <a:ext cx="3566160" cy="3611880"/>
+            <a:ext cx="3566160" cy="3429000"/>
           </a:xfrm>
           <a:prstGeom prst="roundRect">
             <a:avLst>
@@ -8334,8 +8377,8 @@
         </p:nvSpPr>
         <p:spPr>
           <a:xfrm>
-            <a:off x="4544568" y="1920240"/>
-            <a:ext cx="3063240" cy="2743200"/>
+            <a:off x="4544568" y="1965960"/>
+            <a:ext cx="3063240" cy="2651760"/>
           </a:xfrm>
           <a:prstGeom prst="rect">
             <a:avLst/>
@@ -8350,7 +8393,7 @@
           <a:p>
             <a:pPr marL="274320" indent="-274320">
               <a:spcAft>
-                <a:spcPts val="600"/>
+                <a:spcPts val="1400"/>
               </a:spcAft>
               <a:buClr>
                 <a:srgbClr val="0E8A84"/>
@@ -8359,19 +8402,19 @@
               <a:buChar char="•"/>
             </a:pPr>
             <a:r>
-              <a:rPr sz="1700" b="0" i="0">
+              <a:rPr sz="1800" b="0" i="0">
                 <a:solidFill>
                   <a:srgbClr val="1A1A1A"/>
                 </a:solidFill>
                 <a:latin typeface="Calibri"/>
               </a:rPr>
-              <a:t>Calibrate impact on market moves</a:t>
+              <a:t>Calibrate on market moves</a:t>
             </a:r>
           </a:p>
           <a:p>
             <a:pPr marL="274320" indent="-274320">
               <a:spcAft>
-                <a:spcPts val="600"/>
+                <a:spcPts val="1400"/>
               </a:spcAft>
               <a:buClr>
                 <a:srgbClr val="0E8A84"/>
@@ -8380,7 +8423,7 @@
               <a:buChar char="•"/>
             </a:pPr>
             <a:r>
-              <a:rPr sz="1700" b="0" i="0">
+              <a:rPr sz="1800" b="0" i="0">
                 <a:solidFill>
                   <a:srgbClr val="1A1A1A"/>
                 </a:solidFill>
@@ -8392,7 +8435,7 @@
           <a:p>
             <a:pPr marL="274320" indent="-274320">
               <a:spcAft>
-                <a:spcPts val="600"/>
+                <a:spcPts val="1400"/>
               </a:spcAft>
               <a:buClr>
                 <a:srgbClr val="0E8A84"/>
@@ -8401,19 +8444,19 @@
               <a:buChar char="•"/>
             </a:pPr>
             <a:r>
-              <a:rPr sz="1700" b="0" i="0">
+              <a:rPr sz="1800" b="0" i="0">
                 <a:solidFill>
                   <a:srgbClr val="1A1A1A"/>
                 </a:solidFill>
                 <a:latin typeface="Calibri"/>
               </a:rPr>
-              <a:t>Fine-tuned models on public labels (notebook ready)</a:t>
+              <a:t>Fine-tuned models (ready)</a:t>
             </a:r>
           </a:p>
           <a:p>
             <a:pPr marL="274320" indent="-274320">
               <a:spcAft>
-                <a:spcPts val="600"/>
+                <a:spcPts val="1400"/>
               </a:spcAft>
               <a:buClr>
                 <a:srgbClr val="0E8A84"/>
@@ -8422,19 +8465,19 @@
               <a:buChar char="•"/>
             </a:pPr>
             <a:r>
-              <a:rPr sz="1700" b="0" i="0">
+              <a:rPr sz="1800" b="0" i="0">
                 <a:solidFill>
                   <a:srgbClr val="1A1A1A"/>
                 </a:solidFill>
                 <a:latin typeface="Calibri"/>
               </a:rPr>
-              <a:t>Kafka streaming</a:t>
+              <a:t>Streaming (Kafka)</a:t>
             </a:r>
           </a:p>
           <a:p>
             <a:pPr marL="274320" indent="-274320">
               <a:spcAft>
-                <a:spcPts val="600"/>
+                <a:spcPts val="1400"/>
               </a:spcAft>
               <a:buClr>
                 <a:srgbClr val="0E8A84"/>
@@ -8443,13 +8486,13 @@
               <a:buChar char="•"/>
             </a:pPr>
             <a:r>
-              <a:rPr sz="1700" b="0" i="0">
+              <a:rPr sz="1800" b="0" i="0">
                 <a:solidFill>
                   <a:srgbClr val="1A1A1A"/>
                 </a:solidFill>
                 <a:latin typeface="Calibri"/>
               </a:rPr>
-              <a:t>Backtesting and full revaluation</a:t>
+              <a:t>Backtesting</a:t>
             </a:r>
           </a:p>
         </p:txBody>
@@ -8463,7 +8506,7 @@
         <p:spPr>
           <a:xfrm>
             <a:off x="7991856" y="1188720"/>
-            <a:ext cx="3566160" cy="3611880"/>
+            <a:ext cx="3566160" cy="3429000"/>
           </a:xfrm>
           <a:prstGeom prst="roundRect">
             <a:avLst>
@@ -8543,8 +8586,8 @@
         </p:nvSpPr>
         <p:spPr>
           <a:xfrm>
-            <a:off x="8266176" y="1920240"/>
-            <a:ext cx="3063240" cy="2743200"/>
+            <a:off x="8266176" y="1965960"/>
+            <a:ext cx="3063240" cy="2651760"/>
           </a:xfrm>
           <a:prstGeom prst="rect">
             <a:avLst/>
@@ -8559,7 +8602,7 @@
           <a:p>
             <a:pPr marL="274320" indent="-274320">
               <a:spcAft>
-                <a:spcPts val="600"/>
+                <a:spcPts val="1400"/>
               </a:spcAft>
               <a:buClr>
                 <a:srgbClr val="0E8A84"/>
@@ -8568,7 +8611,7 @@
               <a:buChar char="•"/>
             </a:pPr>
             <a:r>
-              <a:rPr sz="1700" b="0" i="0">
+              <a:rPr sz="1800" b="0" i="0">
                 <a:solidFill>
                   <a:srgbClr val="1A1A1A"/>
                 </a:solidFill>
@@ -8580,7 +8623,7 @@
           <a:p>
             <a:pPr marL="274320" indent="-274320">
               <a:spcAft>
-                <a:spcPts val="600"/>
+                <a:spcPts val="1400"/>
               </a:spcAft>
               <a:buClr>
                 <a:srgbClr val="0E8A84"/>
@@ -8589,19 +8632,19 @@
               <a:buChar char="•"/>
             </a:pPr>
             <a:r>
-              <a:rPr sz="1700" b="0" i="0">
+              <a:rPr sz="1800" b="0" i="0">
                 <a:solidFill>
                   <a:srgbClr val="1A1A1A"/>
                 </a:solidFill>
                 <a:latin typeface="Calibri"/>
               </a:rPr>
-              <a:t>One pipeline for every input</a:t>
+              <a:t>One pipeline for all input</a:t>
             </a:r>
           </a:p>
           <a:p>
             <a:pPr marL="274320" indent="-274320">
               <a:spcAft>
-                <a:spcPts val="600"/>
+                <a:spcPts val="1400"/>
               </a:spcAft>
               <a:buClr>
                 <a:srgbClr val="0E8A84"/>
@@ -8610,7 +8653,7 @@
               <a:buChar char="•"/>
             </a:pPr>
             <a:r>
-              <a:rPr sz="1700" b="0" i="0">
+              <a:rPr sz="1800" b="0" i="0">
                 <a:solidFill>
                   <a:srgbClr val="1A1A1A"/>
                 </a:solidFill>
@@ -8622,7 +8665,7 @@
           <a:p>
             <a:pPr marL="274320" indent="-274320">
               <a:spcAft>
-                <a:spcPts val="600"/>
+                <a:spcPts val="1400"/>
               </a:spcAft>
               <a:buClr>
                 <a:srgbClr val="0E8A84"/>
@@ -8631,7 +8674,7 @@
               <a:buChar char="•"/>
             </a:pPr>
             <a:r>
-              <a:rPr sz="1700" b="0" i="0">
+              <a:rPr sz="1800" b="0" i="0">
                 <a:solidFill>
                   <a:srgbClr val="1A1A1A"/>
                 </a:solidFill>
@@ -8643,7 +8686,7 @@
           <a:p>
             <a:pPr marL="274320" indent="-274320">
               <a:spcAft>
-                <a:spcPts val="600"/>
+                <a:spcPts val="1400"/>
               </a:spcAft>
               <a:buClr>
                 <a:srgbClr val="0E8A84"/>
@@ -8652,13 +8695,13 @@
               <a:buChar char="•"/>
             </a:pPr>
             <a:r>
-              <a:rPr sz="1700" b="0" i="0">
+              <a:rPr sz="1800" b="0" i="0">
                 <a:solidFill>
                   <a:srgbClr val="1A1A1A"/>
                 </a:solidFill>
                 <a:latin typeface="Calibri"/>
               </a:rPr>
-              <a:t>Offline demo on a laptop</a:t>
+              <a:t>Offline laptop demo</a:t>
             </a:r>
           </a:p>
         </p:txBody>
@@ -8671,8 +8714,8 @@
         </p:nvSpPr>
         <p:spPr>
           <a:xfrm>
-            <a:off x="548640" y="5029200"/>
-            <a:ext cx="11094415" cy="1051560"/>
+            <a:off x="548640" y="4892040"/>
+            <a:ext cx="11094415" cy="1097280"/>
           </a:xfrm>
           <a:prstGeom prst="roundRect">
             <a:avLst>
@@ -8717,8 +8760,8 @@
         </p:nvSpPr>
         <p:spPr>
           <a:xfrm>
-            <a:off x="914400" y="5029200"/>
-            <a:ext cx="10362895" cy="1051560"/>
+            <a:off x="914400" y="4892040"/>
+            <a:ext cx="10362895" cy="1097280"/>
           </a:xfrm>
           <a:prstGeom prst="rect">
             <a:avLst/>
@@ -8739,7 +8782,7 @@
                 </a:solidFill>
                 <a:latin typeface="Calibri"/>
               </a:rPr>
-              <a:t>An honest, explainable bridge from text to portfolio risk that runs offline on a laptop.</a:t>
+              <a:t>An honest, explainable bridge from text to portfolio risk, offline on a laptop</a:t>
             </a:r>
           </a:p>
         </p:txBody>
@@ -8768,13 +8811,13 @@
           <a:p>
             <a:pPr algn="l"/>
             <a:r>
-              <a:rPr sz="1100" b="0" i="0">
+              <a:rPr sz="1800" b="0" i="0">
                 <a:solidFill>
                   <a:srgbClr val="555B66"/>
                 </a:solidFill>
                 <a:latin typeface="Calibri"/>
               </a:rPr>
-              <a:t>Risk Signal Engine · Code to Connect 2026 · decision-support prototype, not investment advice</a:t>
+              <a:t>Risk Signal Engine · decision support, not investment advice</a:t>
             </a:r>
           </a:p>
         </p:txBody>
@@ -8803,7 +8846,7 @@
           <a:p>
             <a:pPr algn="r"/>
             <a:r>
-              <a:rPr sz="1100" b="0" i="0">
+              <a:rPr sz="1800" b="0" i="0">
                 <a:solidFill>
                   <a:srgbClr val="555B66"/>
                 </a:solidFill>

</xml_diff>